<commit_message>
Fix overlapping layout bugs in architecture deck
Slide 3: row = i // 2 with col = i % 3 on 6 items produced 3 rows,
pushing the bottom row into the useMemo section. Fixed to i // 3 so
6 items lay out as a clean 3-column × 2-row grid.

Slide 10: component pattern descriptions were placed at x=8.15 (width 5"),
landing directly on top of the shadow system boxes at x=8.4. Moved
descriptions below each name box, constrained to the middle column
(x=5.2–8.05). Adjusted start y and step to prevent slide overflow.

Co-Authored-By: Claude Sonnet 4.6 <noreply@anthropic.com>
Claude-Session: https://claude.ai/code/session_012EFETGbhdxdnPCjpmQ9UDz
</commit_message>
<xml_diff>
--- a/Santander_Architecture.pptx
+++ b/Santander_Architecture.pptx
@@ -6999,8 +6999,8 @@
         </p:nvSpPr>
         <p:spPr>
           <a:xfrm>
-            <a:off x="4754880" y="4224528"/>
-            <a:ext cx="2743200" cy="256032"/>
+            <a:off x="4754880" y="3950208"/>
+            <a:ext cx="2606040" cy="256032"/>
           </a:xfrm>
           <a:prstGeom prst="rect">
             <a:avLst/>
@@ -7034,8 +7034,8 @@
         </p:nvSpPr>
         <p:spPr>
           <a:xfrm>
-            <a:off x="4754880" y="4526280"/>
-            <a:ext cx="2606040" cy="420624"/>
+            <a:off x="4754880" y="4261104"/>
+            <a:ext cx="2606040" cy="256032"/>
           </a:xfrm>
           <a:prstGeom prst="rect">
             <a:avLst/>
@@ -7077,8 +7077,8 @@
         </p:nvSpPr>
         <p:spPr>
           <a:xfrm>
-            <a:off x="4864608" y="4581144"/>
-            <a:ext cx="2395728" cy="219456"/>
+            <a:off x="4864608" y="4297680"/>
+            <a:ext cx="2395728" cy="201168"/>
           </a:xfrm>
           <a:prstGeom prst="rect">
             <a:avLst/>
@@ -7112,8 +7112,8 @@
         </p:nvSpPr>
         <p:spPr>
           <a:xfrm>
-            <a:off x="7452360" y="4617720"/>
-            <a:ext cx="4572000" cy="329184"/>
+            <a:off x="4773168" y="4535424"/>
+            <a:ext cx="2542032" cy="164592"/>
           </a:xfrm>
           <a:prstGeom prst="rect">
             <a:avLst/>
@@ -7128,7 +7128,7 @@
           <a:p>
             <a:pPr algn="l"/>
             <a:r>
-              <a:rPr sz="850" b="0" i="0">
+              <a:rPr sz="750" b="0" i="0">
                 <a:solidFill>
                   <a:srgbClr val="78716C"/>
                 </a:solidFill>
@@ -7147,8 +7147,8 @@
         </p:nvSpPr>
         <p:spPr>
           <a:xfrm>
-            <a:off x="4754880" y="5029200"/>
-            <a:ext cx="2606040" cy="420624"/>
+            <a:off x="4754880" y="4736592"/>
+            <a:ext cx="2606040" cy="256032"/>
           </a:xfrm>
           <a:prstGeom prst="rect">
             <a:avLst/>
@@ -7190,8 +7190,8 @@
         </p:nvSpPr>
         <p:spPr>
           <a:xfrm>
-            <a:off x="4864608" y="5084064"/>
-            <a:ext cx="2395728" cy="219456"/>
+            <a:off x="4864608" y="4773168"/>
+            <a:ext cx="2395728" cy="201168"/>
           </a:xfrm>
           <a:prstGeom prst="rect">
             <a:avLst/>
@@ -7225,8 +7225,8 @@
         </p:nvSpPr>
         <p:spPr>
           <a:xfrm>
-            <a:off x="7452360" y="5120640"/>
-            <a:ext cx="4572000" cy="329184"/>
+            <a:off x="4773168" y="5010912"/>
+            <a:ext cx="2542032" cy="164592"/>
           </a:xfrm>
           <a:prstGeom prst="rect">
             <a:avLst/>
@@ -7241,7 +7241,7 @@
           <a:p>
             <a:pPr algn="l"/>
             <a:r>
-              <a:rPr sz="850" b="0" i="0">
+              <a:rPr sz="750" b="0" i="0">
                 <a:solidFill>
                   <a:srgbClr val="78716C"/>
                 </a:solidFill>
@@ -7260,8 +7260,8 @@
         </p:nvSpPr>
         <p:spPr>
           <a:xfrm>
-            <a:off x="4754880" y="5532120"/>
-            <a:ext cx="2606040" cy="420624"/>
+            <a:off x="4754880" y="5212080"/>
+            <a:ext cx="2606040" cy="256032"/>
           </a:xfrm>
           <a:prstGeom prst="rect">
             <a:avLst/>
@@ -7303,8 +7303,8 @@
         </p:nvSpPr>
         <p:spPr>
           <a:xfrm>
-            <a:off x="4864608" y="5586984"/>
-            <a:ext cx="2395728" cy="219456"/>
+            <a:off x="4864608" y="5248656"/>
+            <a:ext cx="2395728" cy="201168"/>
           </a:xfrm>
           <a:prstGeom prst="rect">
             <a:avLst/>
@@ -7338,8 +7338,8 @@
         </p:nvSpPr>
         <p:spPr>
           <a:xfrm>
-            <a:off x="7452360" y="5623560"/>
-            <a:ext cx="4572000" cy="329184"/>
+            <a:off x="4773168" y="5486400"/>
+            <a:ext cx="2542032" cy="164592"/>
           </a:xfrm>
           <a:prstGeom prst="rect">
             <a:avLst/>
@@ -7354,7 +7354,7 @@
           <a:p>
             <a:pPr algn="l"/>
             <a:r>
-              <a:rPr sz="850" b="0" i="0">
+              <a:rPr sz="750" b="0" i="0">
                 <a:solidFill>
                   <a:srgbClr val="78716C"/>
                 </a:solidFill>
@@ -7373,8 +7373,8 @@
         </p:nvSpPr>
         <p:spPr>
           <a:xfrm>
-            <a:off x="4754880" y="6035040"/>
-            <a:ext cx="2606040" cy="420624"/>
+            <a:off x="4754880" y="5687568"/>
+            <a:ext cx="2606040" cy="256032"/>
           </a:xfrm>
           <a:prstGeom prst="rect">
             <a:avLst/>
@@ -7416,8 +7416,8 @@
         </p:nvSpPr>
         <p:spPr>
           <a:xfrm>
-            <a:off x="4864608" y="6089904"/>
-            <a:ext cx="2395728" cy="219456"/>
+            <a:off x="4864608" y="5724144"/>
+            <a:ext cx="2395728" cy="201168"/>
           </a:xfrm>
           <a:prstGeom prst="rect">
             <a:avLst/>
@@ -7451,8 +7451,8 @@
         </p:nvSpPr>
         <p:spPr>
           <a:xfrm>
-            <a:off x="7452360" y="6126480"/>
-            <a:ext cx="4572000" cy="329184"/>
+            <a:off x="4773168" y="5961888"/>
+            <a:ext cx="2542032" cy="164592"/>
           </a:xfrm>
           <a:prstGeom prst="rect">
             <a:avLst/>
@@ -7467,7 +7467,7 @@
           <a:p>
             <a:pPr algn="l"/>
             <a:r>
-              <a:rPr sz="850" b="0" i="0">
+              <a:rPr sz="750" b="0" i="0">
                 <a:solidFill>
                   <a:srgbClr val="78716C"/>
                 </a:solidFill>
@@ -7486,8 +7486,8 @@
         </p:nvSpPr>
         <p:spPr>
           <a:xfrm>
-            <a:off x="4754880" y="6537960"/>
-            <a:ext cx="2606040" cy="420624"/>
+            <a:off x="4754880" y="6163056"/>
+            <a:ext cx="2606040" cy="256032"/>
           </a:xfrm>
           <a:prstGeom prst="rect">
             <a:avLst/>
@@ -7529,8 +7529,8 @@
         </p:nvSpPr>
         <p:spPr>
           <a:xfrm>
-            <a:off x="4864608" y="6592824"/>
-            <a:ext cx="2395728" cy="219456"/>
+            <a:off x="4864608" y="6199632"/>
+            <a:ext cx="2395728" cy="201168"/>
           </a:xfrm>
           <a:prstGeom prst="rect">
             <a:avLst/>
@@ -7564,8 +7564,8 @@
         </p:nvSpPr>
         <p:spPr>
           <a:xfrm>
-            <a:off x="7452360" y="6629400"/>
-            <a:ext cx="4572000" cy="329184"/>
+            <a:off x="4773168" y="6437376"/>
+            <a:ext cx="2542032" cy="164592"/>
           </a:xfrm>
           <a:prstGeom prst="rect">
             <a:avLst/>
@@ -7580,7 +7580,7 @@
           <a:p>
             <a:pPr algn="l"/>
             <a:r>
-              <a:rPr sz="850" b="0" i="0">
+              <a:rPr sz="750" b="0" i="0">
                 <a:solidFill>
                   <a:srgbClr val="78716C"/>
                 </a:solidFill>
@@ -11066,7 +11066,7 @@
         </p:nvSpPr>
         <p:spPr>
           <a:xfrm>
-            <a:off x="8293608" y="3108960"/>
+            <a:off x="8293608" y="1719072"/>
             <a:ext cx="3657600" cy="1261872"/>
           </a:xfrm>
           <a:prstGeom prst="rect">
@@ -11111,7 +11111,7 @@
         </p:nvSpPr>
         <p:spPr>
           <a:xfrm>
-            <a:off x="8293608" y="3108960"/>
+            <a:off x="8293608" y="1719072"/>
             <a:ext cx="3657600" cy="64008"/>
           </a:xfrm>
           <a:prstGeom prst="rect">
@@ -11154,7 +11154,7 @@
         </p:nvSpPr>
         <p:spPr>
           <a:xfrm>
-            <a:off x="8403336" y="3200400"/>
+            <a:off x="8403336" y="1810512"/>
             <a:ext cx="3383280" cy="228600"/>
           </a:xfrm>
           <a:prstGeom prst="rect">
@@ -11189,7 +11189,7 @@
         </p:nvSpPr>
         <p:spPr>
           <a:xfrm>
-            <a:off x="8403336" y="3456432"/>
+            <a:off x="8403336" y="2066543"/>
             <a:ext cx="3383280" cy="4572000"/>
           </a:xfrm>
           <a:prstGeom prst="rect">
@@ -11558,7 +11558,7 @@
         </p:nvSpPr>
         <p:spPr>
           <a:xfrm>
-            <a:off x="4398264" y="4498848"/>
+            <a:off x="4398264" y="3108960"/>
             <a:ext cx="3657600" cy="1261872"/>
           </a:xfrm>
           <a:prstGeom prst="rect">
@@ -11603,7 +11603,7 @@
         </p:nvSpPr>
         <p:spPr>
           <a:xfrm>
-            <a:off x="4398264" y="4498848"/>
+            <a:off x="4398264" y="3108960"/>
             <a:ext cx="3657600" cy="64008"/>
           </a:xfrm>
           <a:prstGeom prst="rect">
@@ -11646,7 +11646,7 @@
         </p:nvSpPr>
         <p:spPr>
           <a:xfrm>
-            <a:off x="4507992" y="4590288"/>
+            <a:off x="4507992" y="3200400"/>
             <a:ext cx="3383280" cy="228600"/>
           </a:xfrm>
           <a:prstGeom prst="rect">
@@ -11681,7 +11681,7 @@
         </p:nvSpPr>
         <p:spPr>
           <a:xfrm>
-            <a:off x="4507992" y="4846320"/>
+            <a:off x="4507992" y="3456432"/>
             <a:ext cx="3383280" cy="4572000"/>
           </a:xfrm>
           <a:prstGeom prst="rect">
@@ -11804,7 +11804,7 @@
         </p:nvSpPr>
         <p:spPr>
           <a:xfrm>
-            <a:off x="8293608" y="4498848"/>
+            <a:off x="8293608" y="3108960"/>
             <a:ext cx="3657600" cy="1261872"/>
           </a:xfrm>
           <a:prstGeom prst="rect">
@@ -11849,7 +11849,7 @@
         </p:nvSpPr>
         <p:spPr>
           <a:xfrm>
-            <a:off x="8293608" y="4498848"/>
+            <a:off x="8293608" y="3108960"/>
             <a:ext cx="3657600" cy="64008"/>
           </a:xfrm>
           <a:prstGeom prst="rect">
@@ -11892,7 +11892,7 @@
         </p:nvSpPr>
         <p:spPr>
           <a:xfrm>
-            <a:off x="8403336" y="4590288"/>
+            <a:off x="8403336" y="3200400"/>
             <a:ext cx="3383280" cy="228600"/>
           </a:xfrm>
           <a:prstGeom prst="rect">
@@ -11927,7 +11927,7 @@
         </p:nvSpPr>
         <p:spPr>
           <a:xfrm>
-            <a:off x="8403336" y="4846320"/>
+            <a:off x="8403336" y="3456432"/>
             <a:ext cx="3383280" cy="4572000"/>
           </a:xfrm>
           <a:prstGeom prst="rect">

</xml_diff>

<commit_message>
Fix text overflow: add MSO_AUTO_SIZE.TEXT_TO_FIT_SHAPE to all text frames
All five build scripts updated — every text box now carries auto_size so
PowerPoint shrinks text to fit its container rather than overflowing into
adjacent elements. Applied to T(), ML(), txt(), ml(), text(), multiline(),
and bullets_box() helpers across all scripts.

Co-Authored-By: Claude Opus 4.8 <noreply@anthropic.com>
Claude-Session: https://claude.ai/code/session_012EFETGbhdxdnPCjpmQ9UDz
</commit_message>
<xml_diff>
--- a/Santander_Architecture.pptx
+++ b/Santander_Architecture.pptx
@@ -3459,7 +3459,7 @@
         </p:spPr>
         <p:txBody>
           <a:bodyPr wrap="square">
-            <a:spAutoFit/>
+            <a:normAutofit/>
           </a:bodyPr>
           <a:lstStyle/>
           <a:p>
@@ -3772,7 +3772,7 @@
         </p:spPr>
         <p:txBody>
           <a:bodyPr wrap="square">
-            <a:spAutoFit/>
+            <a:normAutofit/>
           </a:bodyPr>
           <a:lstStyle/>
           <a:p>
@@ -3875,7 +3875,7 @@
         </p:spPr>
         <p:txBody>
           <a:bodyPr wrap="square">
-            <a:spAutoFit/>
+            <a:normAutofit/>
           </a:bodyPr>
           <a:lstStyle/>
           <a:p>
@@ -4167,7 +4167,7 @@
         </p:spPr>
         <p:txBody>
           <a:bodyPr wrap="square">
-            <a:spAutoFit/>
+            <a:normAutofit/>
           </a:bodyPr>
           <a:lstStyle/>
           <a:p>
@@ -4464,7 +4464,7 @@
         </p:spPr>
         <p:txBody>
           <a:bodyPr wrap="square">
-            <a:spAutoFit/>
+            <a:normAutofit/>
           </a:bodyPr>
           <a:lstStyle/>
           <a:p>
@@ -5706,7 +5706,7 @@
         </p:spPr>
         <p:txBody>
           <a:bodyPr wrap="square">
-            <a:spAutoFit/>
+            <a:normAutofit/>
           </a:bodyPr>
           <a:lstStyle/>
           <a:p>
@@ -7048,7 +7048,7 @@
         </p:spPr>
         <p:txBody>
           <a:bodyPr wrap="square">
-            <a:spAutoFit/>
+            <a:normAutofit/>
           </a:bodyPr>
           <a:lstStyle/>
           <a:p>
@@ -7153,7 +7153,7 @@
         </p:spPr>
         <p:txBody>
           <a:bodyPr wrap="square">
-            <a:spAutoFit/>
+            <a:normAutofit/>
           </a:bodyPr>
           <a:lstStyle/>
           <a:p>

</xml_diff>

<commit_message>
fix: reduce text overflow in all 5 PowerPoint decks
- Reduce body font sizes across all decks: 11.5pt → 10pt, 12.5pt → 11pt
- Increase text box heights to use more of the available slide area
- Split walkthrough MTD submission slide into Part 1 (5 steps) + Part 2 (design rationale)
- Split walkthrough demo script slide into Opening/CC/VAT + Mandate/Closing slides
- Add a dedicated Command Centre demo section slide
- Reduce line spacing from 5pt → 4pt space_after in dense content areas
- Architecture deck: reduce bullets_box default from 15pt → 13pt
- Future deck: reduce command centre right panel and compliance panels to 10pt

Walkthrough grows from 21 → 24 slides with the added Part 2 splits.
All 5 decks rebuilt and verified.
</commit_message>
<xml_diff>
--- a/Santander_Architecture.pptx
+++ b/Santander_Architecture.pptx
@@ -3465,11 +3465,11 @@
           <a:p>
             <a:pPr>
               <a:spcBef>
-                <a:spcPts val="600"/>
+                <a:spcPts val="500"/>
               </a:spcBef>
             </a:pPr>
             <a:r>
-              <a:rPr sz="1500">
+              <a:rPr sz="1300">
                 <a:solidFill>
                   <a:srgbClr val="1C1917"/>
                 </a:solidFill>
@@ -3481,11 +3481,11 @@
           <a:p>
             <a:pPr>
               <a:spcBef>
-                <a:spcPts val="600"/>
+                <a:spcPts val="500"/>
               </a:spcBef>
             </a:pPr>
             <a:r>
-              <a:rPr sz="1500">
+              <a:rPr sz="1300">
                 <a:solidFill>
                   <a:srgbClr val="1C1917"/>
                 </a:solidFill>
@@ -3497,11 +3497,11 @@
           <a:p>
             <a:pPr>
               <a:spcBef>
-                <a:spcPts val="600"/>
+                <a:spcPts val="500"/>
               </a:spcBef>
             </a:pPr>
             <a:r>
-              <a:rPr sz="1500">
+              <a:rPr sz="1300">
                 <a:solidFill>
                   <a:srgbClr val="1C1917"/>
                 </a:solidFill>
@@ -3513,11 +3513,11 @@
           <a:p>
             <a:pPr>
               <a:spcBef>
-                <a:spcPts val="600"/>
+                <a:spcPts val="500"/>
               </a:spcBef>
             </a:pPr>
             <a:r>
-              <a:rPr sz="1500">
+              <a:rPr sz="1300">
                 <a:solidFill>
                   <a:srgbClr val="1C1917"/>
                 </a:solidFill>
@@ -3529,11 +3529,11 @@
           <a:p>
             <a:pPr>
               <a:spcBef>
-                <a:spcPts val="600"/>
+                <a:spcPts val="500"/>
               </a:spcBef>
             </a:pPr>
             <a:r>
-              <a:rPr sz="1500">
+              <a:rPr sz="1300">
                 <a:solidFill>
                   <a:srgbClr val="1C1917"/>
                 </a:solidFill>
@@ -3545,11 +3545,11 @@
           <a:p>
             <a:pPr>
               <a:spcBef>
-                <a:spcPts val="600"/>
+                <a:spcPts val="500"/>
               </a:spcBef>
             </a:pPr>
             <a:r>
-              <a:rPr sz="1500">
+              <a:rPr sz="1300">
                 <a:solidFill>
                   <a:srgbClr val="1C1917"/>
                 </a:solidFill>
@@ -3561,11 +3561,11 @@
           <a:p>
             <a:pPr>
               <a:spcBef>
-                <a:spcPts val="600"/>
+                <a:spcPts val="500"/>
               </a:spcBef>
             </a:pPr>
             <a:r>
-              <a:rPr sz="1500">
+              <a:rPr sz="1300">
                 <a:solidFill>
                   <a:srgbClr val="1C1917"/>
                 </a:solidFill>
@@ -3577,11 +3577,11 @@
           <a:p>
             <a:pPr>
               <a:spcBef>
-                <a:spcPts val="600"/>
+                <a:spcPts val="500"/>
               </a:spcBef>
             </a:pPr>
             <a:r>
-              <a:rPr sz="1500">
+              <a:rPr sz="1300">
                 <a:solidFill>
                   <a:srgbClr val="1C1917"/>
                 </a:solidFill>
@@ -3593,11 +3593,11 @@
           <a:p>
             <a:pPr>
               <a:spcBef>
-                <a:spcPts val="600"/>
+                <a:spcPts val="500"/>
               </a:spcBef>
             </a:pPr>
             <a:r>
-              <a:rPr sz="1500">
+              <a:rPr sz="1300">
                 <a:solidFill>
                   <a:srgbClr val="1C1917"/>
                 </a:solidFill>
@@ -3778,11 +3778,11 @@
           <a:p>
             <a:pPr>
               <a:spcBef>
-                <a:spcPts val="600"/>
+                <a:spcPts val="500"/>
               </a:spcBef>
             </a:pPr>
             <a:r>
-              <a:rPr sz="1400">
+              <a:rPr sz="1300">
                 <a:solidFill>
                   <a:srgbClr val="1C1917"/>
                 </a:solidFill>
@@ -3794,11 +3794,11 @@
           <a:p>
             <a:pPr>
               <a:spcBef>
-                <a:spcPts val="600"/>
+                <a:spcPts val="500"/>
               </a:spcBef>
             </a:pPr>
             <a:r>
-              <a:rPr sz="1400">
+              <a:rPr sz="1300">
                 <a:solidFill>
                   <a:srgbClr val="1C1917"/>
                 </a:solidFill>
@@ -3810,11 +3810,11 @@
           <a:p>
             <a:pPr>
               <a:spcBef>
-                <a:spcPts val="600"/>
+                <a:spcPts val="500"/>
               </a:spcBef>
             </a:pPr>
             <a:r>
-              <a:rPr sz="1400">
+              <a:rPr sz="1300">
                 <a:solidFill>
                   <a:srgbClr val="1C1917"/>
                 </a:solidFill>
@@ -3826,11 +3826,11 @@
           <a:p>
             <a:pPr>
               <a:spcBef>
-                <a:spcPts val="600"/>
+                <a:spcPts val="500"/>
               </a:spcBef>
             </a:pPr>
             <a:r>
-              <a:rPr sz="1400">
+              <a:rPr sz="1300">
                 <a:solidFill>
                   <a:srgbClr val="1C1917"/>
                 </a:solidFill>
@@ -3842,11 +3842,11 @@
           <a:p>
             <a:pPr>
               <a:spcBef>
-                <a:spcPts val="600"/>
+                <a:spcPts val="500"/>
               </a:spcBef>
             </a:pPr>
             <a:r>
-              <a:rPr sz="1400">
+              <a:rPr sz="1300">
                 <a:solidFill>
                   <a:srgbClr val="1C1917"/>
                 </a:solidFill>
@@ -3881,11 +3881,11 @@
           <a:p>
             <a:pPr>
               <a:spcBef>
-                <a:spcPts val="600"/>
+                <a:spcPts val="500"/>
               </a:spcBef>
             </a:pPr>
             <a:r>
-              <a:rPr sz="1400">
+              <a:rPr sz="1300">
                 <a:solidFill>
                   <a:srgbClr val="1C1917"/>
                 </a:solidFill>
@@ -3897,11 +3897,11 @@
           <a:p>
             <a:pPr>
               <a:spcBef>
-                <a:spcPts val="600"/>
+                <a:spcPts val="500"/>
               </a:spcBef>
             </a:pPr>
             <a:r>
-              <a:rPr sz="1400">
+              <a:rPr sz="1300">
                 <a:solidFill>
                   <a:srgbClr val="1C1917"/>
                 </a:solidFill>
@@ -3913,11 +3913,11 @@
           <a:p>
             <a:pPr>
               <a:spcBef>
-                <a:spcPts val="600"/>
+                <a:spcPts val="500"/>
               </a:spcBef>
             </a:pPr>
             <a:r>
-              <a:rPr sz="1400">
+              <a:rPr sz="1300">
                 <a:solidFill>
                   <a:srgbClr val="1C1917"/>
                 </a:solidFill>
@@ -3929,11 +3929,11 @@
           <a:p>
             <a:pPr>
               <a:spcBef>
-                <a:spcPts val="600"/>
+                <a:spcPts val="500"/>
               </a:spcBef>
             </a:pPr>
             <a:r>
-              <a:rPr sz="1400">
+              <a:rPr sz="1300">
                 <a:solidFill>
                   <a:srgbClr val="1C1917"/>
                 </a:solidFill>
@@ -3945,11 +3945,11 @@
           <a:p>
             <a:pPr>
               <a:spcBef>
-                <a:spcPts val="600"/>
+                <a:spcPts val="500"/>
               </a:spcBef>
             </a:pPr>
             <a:r>
-              <a:rPr sz="1400">
+              <a:rPr sz="1300">
                 <a:solidFill>
                   <a:srgbClr val="1C1917"/>
                 </a:solidFill>
@@ -4173,11 +4173,11 @@
           <a:p>
             <a:pPr>
               <a:spcBef>
-                <a:spcPts val="600"/>
+                <a:spcPts val="500"/>
               </a:spcBef>
             </a:pPr>
             <a:r>
-              <a:rPr sz="1500">
+              <a:rPr sz="1300">
                 <a:solidFill>
                   <a:srgbClr val="1C1917"/>
                 </a:solidFill>
@@ -4189,11 +4189,11 @@
           <a:p>
             <a:pPr>
               <a:spcBef>
-                <a:spcPts val="600"/>
+                <a:spcPts val="500"/>
               </a:spcBef>
             </a:pPr>
             <a:r>
-              <a:rPr sz="1500">
+              <a:rPr sz="1300">
                 <a:solidFill>
                   <a:srgbClr val="1C1917"/>
                 </a:solidFill>
@@ -4205,11 +4205,11 @@
           <a:p>
             <a:pPr>
               <a:spcBef>
-                <a:spcPts val="600"/>
+                <a:spcPts val="500"/>
               </a:spcBef>
             </a:pPr>
             <a:r>
-              <a:rPr sz="1500">
+              <a:rPr sz="1300">
                 <a:solidFill>
                   <a:srgbClr val="1C1917"/>
                 </a:solidFill>
@@ -4221,11 +4221,11 @@
           <a:p>
             <a:pPr>
               <a:spcBef>
-                <a:spcPts val="600"/>
+                <a:spcPts val="500"/>
               </a:spcBef>
             </a:pPr>
             <a:r>
-              <a:rPr sz="1500">
+              <a:rPr sz="1300">
                 <a:solidFill>
                   <a:srgbClr val="1C1917"/>
                 </a:solidFill>
@@ -4237,11 +4237,11 @@
           <a:p>
             <a:pPr>
               <a:spcBef>
-                <a:spcPts val="600"/>
+                <a:spcPts val="500"/>
               </a:spcBef>
             </a:pPr>
             <a:r>
-              <a:rPr sz="1500">
+              <a:rPr sz="1300">
                 <a:solidFill>
                   <a:srgbClr val="1C1917"/>
                 </a:solidFill>
@@ -4253,11 +4253,11 @@
           <a:p>
             <a:pPr>
               <a:spcBef>
-                <a:spcPts val="600"/>
+                <a:spcPts val="500"/>
               </a:spcBef>
             </a:pPr>
             <a:r>
-              <a:rPr sz="1500">
+              <a:rPr sz="1300">
                 <a:solidFill>
                   <a:srgbClr val="1C1917"/>
                 </a:solidFill>
@@ -4269,11 +4269,11 @@
           <a:p>
             <a:pPr>
               <a:spcBef>
-                <a:spcPts val="600"/>
+                <a:spcPts val="500"/>
               </a:spcBef>
             </a:pPr>
             <a:r>
-              <a:rPr sz="1500">
+              <a:rPr sz="1300">
                 <a:solidFill>
                   <a:srgbClr val="1C1917"/>
                 </a:solidFill>
@@ -4285,11 +4285,11 @@
           <a:p>
             <a:pPr>
               <a:spcBef>
-                <a:spcPts val="600"/>
+                <a:spcPts val="500"/>
               </a:spcBef>
             </a:pPr>
             <a:r>
-              <a:rPr sz="1500">
+              <a:rPr sz="1300">
                 <a:solidFill>
                   <a:srgbClr val="1C1917"/>
                 </a:solidFill>
@@ -4470,11 +4470,11 @@
           <a:p>
             <a:pPr>
               <a:spcBef>
-                <a:spcPts val="600"/>
+                <a:spcPts val="500"/>
               </a:spcBef>
             </a:pPr>
             <a:r>
-              <a:rPr sz="1500">
+              <a:rPr sz="1300">
                 <a:solidFill>
                   <a:srgbClr val="1C1917"/>
                 </a:solidFill>
@@ -4486,11 +4486,11 @@
           <a:p>
             <a:pPr>
               <a:spcBef>
-                <a:spcPts val="600"/>
+                <a:spcPts val="500"/>
               </a:spcBef>
             </a:pPr>
             <a:r>
-              <a:rPr sz="1500">
+              <a:rPr sz="1300">
                 <a:solidFill>
                   <a:srgbClr val="1C1917"/>
                 </a:solidFill>
@@ -4502,11 +4502,11 @@
           <a:p>
             <a:pPr>
               <a:spcBef>
-                <a:spcPts val="600"/>
+                <a:spcPts val="500"/>
               </a:spcBef>
             </a:pPr>
             <a:r>
-              <a:rPr sz="1500">
+              <a:rPr sz="1300">
                 <a:solidFill>
                   <a:srgbClr val="1C1917"/>
                 </a:solidFill>
@@ -4518,11 +4518,11 @@
           <a:p>
             <a:pPr>
               <a:spcBef>
-                <a:spcPts val="600"/>
+                <a:spcPts val="500"/>
               </a:spcBef>
             </a:pPr>
             <a:r>
-              <a:rPr sz="1500">
+              <a:rPr sz="1300">
                 <a:solidFill>
                   <a:srgbClr val="1C1917"/>
                 </a:solidFill>
@@ -4534,11 +4534,11 @@
           <a:p>
             <a:pPr>
               <a:spcBef>
-                <a:spcPts val="600"/>
+                <a:spcPts val="500"/>
               </a:spcBef>
             </a:pPr>
             <a:r>
-              <a:rPr sz="1500">
+              <a:rPr sz="1300">
                 <a:solidFill>
                   <a:srgbClr val="1C1917"/>
                 </a:solidFill>
@@ -4550,11 +4550,11 @@
           <a:p>
             <a:pPr>
               <a:spcBef>
-                <a:spcPts val="600"/>
+                <a:spcPts val="500"/>
               </a:spcBef>
             </a:pPr>
             <a:r>
-              <a:rPr sz="1500">
+              <a:rPr sz="1300">
                 <a:solidFill>
                   <a:srgbClr val="1C1917"/>
                 </a:solidFill>
@@ -4566,11 +4566,11 @@
           <a:p>
             <a:pPr>
               <a:spcBef>
-                <a:spcPts val="600"/>
+                <a:spcPts val="500"/>
               </a:spcBef>
             </a:pPr>
             <a:r>
-              <a:rPr sz="1500">
+              <a:rPr sz="1300">
                 <a:solidFill>
                   <a:srgbClr val="1C1917"/>
                 </a:solidFill>
@@ -5712,11 +5712,11 @@
           <a:p>
             <a:pPr>
               <a:spcBef>
-                <a:spcPts val="600"/>
+                <a:spcPts val="500"/>
               </a:spcBef>
             </a:pPr>
             <a:r>
-              <a:rPr sz="1500">
+              <a:rPr sz="1300">
                 <a:solidFill>
                   <a:srgbClr val="1C1917"/>
                 </a:solidFill>
@@ -5728,11 +5728,11 @@
           <a:p>
             <a:pPr>
               <a:spcBef>
-                <a:spcPts val="600"/>
+                <a:spcPts val="500"/>
               </a:spcBef>
             </a:pPr>
             <a:r>
-              <a:rPr sz="1500">
+              <a:rPr sz="1300">
                 <a:solidFill>
                   <a:srgbClr val="1C1917"/>
                 </a:solidFill>
@@ -5744,11 +5744,11 @@
           <a:p>
             <a:pPr>
               <a:spcBef>
-                <a:spcPts val="600"/>
+                <a:spcPts val="500"/>
               </a:spcBef>
             </a:pPr>
             <a:r>
-              <a:rPr sz="1500">
+              <a:rPr sz="1300">
                 <a:solidFill>
                   <a:srgbClr val="1C1917"/>
                 </a:solidFill>
@@ -5760,11 +5760,11 @@
           <a:p>
             <a:pPr>
               <a:spcBef>
-                <a:spcPts val="600"/>
+                <a:spcPts val="500"/>
               </a:spcBef>
             </a:pPr>
             <a:r>
-              <a:rPr sz="1500">
+              <a:rPr sz="1300">
                 <a:solidFill>
                   <a:srgbClr val="1C1917"/>
                 </a:solidFill>
@@ -5776,11 +5776,11 @@
           <a:p>
             <a:pPr>
               <a:spcBef>
-                <a:spcPts val="600"/>
+                <a:spcPts val="500"/>
               </a:spcBef>
             </a:pPr>
             <a:r>
-              <a:rPr sz="1500">
+              <a:rPr sz="1300">
                 <a:solidFill>
                   <a:srgbClr val="1C1917"/>
                 </a:solidFill>
@@ -5792,11 +5792,11 @@
           <a:p>
             <a:pPr>
               <a:spcBef>
-                <a:spcPts val="600"/>
+                <a:spcPts val="500"/>
               </a:spcBef>
             </a:pPr>
             <a:r>
-              <a:rPr sz="1500">
+              <a:rPr sz="1300">
                 <a:solidFill>
                   <a:srgbClr val="1C1917"/>
                 </a:solidFill>
@@ -6213,7 +6213,7 @@
               </a:spcBef>
             </a:pPr>
             <a:r>
-              <a:rPr sz="1400">
+              <a:rPr sz="1200">
                 <a:solidFill>
                   <a:srgbClr val="1C1917"/>
                 </a:solidFill>
@@ -6229,7 +6229,7 @@
               </a:spcBef>
             </a:pPr>
             <a:r>
-              <a:rPr sz="1400">
+              <a:rPr sz="1200">
                 <a:solidFill>
                   <a:srgbClr val="1C1917"/>
                 </a:solidFill>
@@ -6245,7 +6245,7 @@
               </a:spcBef>
             </a:pPr>
             <a:r>
-              <a:rPr sz="1400">
+              <a:rPr sz="1200">
                 <a:solidFill>
                   <a:srgbClr val="1C1917"/>
                 </a:solidFill>
@@ -6261,7 +6261,7 @@
               </a:spcBef>
             </a:pPr>
             <a:r>
-              <a:rPr sz="1400">
+              <a:rPr sz="1200">
                 <a:solidFill>
                   <a:srgbClr val="1C1917"/>
                 </a:solidFill>
@@ -6277,7 +6277,7 @@
               </a:spcBef>
             </a:pPr>
             <a:r>
-              <a:rPr sz="1400">
+              <a:rPr sz="1200">
                 <a:solidFill>
                   <a:srgbClr val="1C1917"/>
                 </a:solidFill>
@@ -6462,7 +6462,7 @@
               </a:spcBef>
             </a:pPr>
             <a:r>
-              <a:rPr sz="1500">
+              <a:rPr sz="1300">
                 <a:solidFill>
                   <a:srgbClr val="1C1917"/>
                 </a:solidFill>
@@ -6478,7 +6478,7 @@
               </a:spcBef>
             </a:pPr>
             <a:r>
-              <a:rPr sz="1500">
+              <a:rPr sz="1300">
                 <a:solidFill>
                   <a:srgbClr val="1C1917"/>
                 </a:solidFill>
@@ -6494,7 +6494,7 @@
               </a:spcBef>
             </a:pPr>
             <a:r>
-              <a:rPr sz="1300">
+              <a:rPr sz="1100">
                 <a:solidFill>
                   <a:srgbClr val="78716C"/>
                 </a:solidFill>
@@ -6510,7 +6510,7 @@
               </a:spcBef>
             </a:pPr>
             <a:r>
-              <a:rPr sz="1300">
+              <a:rPr sz="1100">
                 <a:solidFill>
                   <a:srgbClr val="78716C"/>
                 </a:solidFill>
@@ -6526,7 +6526,7 @@
               </a:spcBef>
             </a:pPr>
             <a:r>
-              <a:rPr sz="1300">
+              <a:rPr sz="1100">
                 <a:solidFill>
                   <a:srgbClr val="78716C"/>
                 </a:solidFill>
@@ -6542,7 +6542,7 @@
               </a:spcBef>
             </a:pPr>
             <a:r>
-              <a:rPr sz="1300">
+              <a:rPr sz="1100">
                 <a:solidFill>
                   <a:srgbClr val="78716C"/>
                 </a:solidFill>
@@ -6558,7 +6558,7 @@
               </a:spcBef>
             </a:pPr>
             <a:r>
-              <a:rPr sz="1500">
+              <a:rPr sz="1300">
                 <a:solidFill>
                   <a:srgbClr val="1C1917"/>
                 </a:solidFill>
@@ -7054,7 +7054,7 @@
           <a:p>
             <a:pPr>
               <a:spcBef>
-                <a:spcPts val="600"/>
+                <a:spcPts val="500"/>
               </a:spcBef>
             </a:pPr>
             <a:r>
@@ -7070,7 +7070,7 @@
           <a:p>
             <a:pPr>
               <a:spcBef>
-                <a:spcPts val="600"/>
+                <a:spcPts val="500"/>
               </a:spcBef>
             </a:pPr>
             <a:r>
@@ -7086,7 +7086,7 @@
           <a:p>
             <a:pPr>
               <a:spcBef>
-                <a:spcPts val="600"/>
+                <a:spcPts val="500"/>
               </a:spcBef>
             </a:pPr>
             <a:r>
@@ -7159,7 +7159,7 @@
           <a:p>
             <a:pPr>
               <a:spcBef>
-                <a:spcPts val="600"/>
+                <a:spcPts val="500"/>
               </a:spcBef>
             </a:pPr>
             <a:r>
@@ -7175,7 +7175,7 @@
           <a:p>
             <a:pPr>
               <a:spcBef>
-                <a:spcPts val="600"/>
+                <a:spcPts val="500"/>
               </a:spcBef>
             </a:pPr>
             <a:r>
@@ -7191,7 +7191,7 @@
           <a:p>
             <a:pPr>
               <a:spcBef>
-                <a:spcPts val="600"/>
+                <a:spcPts val="500"/>
               </a:spcBef>
             </a:pPr>
             <a:r>
@@ -7207,7 +7207,7 @@
           <a:p>
             <a:pPr>
               <a:spcBef>
-                <a:spcPts val="600"/>
+                <a:spcPts val="500"/>
               </a:spcBef>
             </a:pPr>
             <a:r>

</xml_diff>

<commit_message>
fix: replace TEXT_TO_FIT_SHAPE with NONE — actually clip text at box bounds
TEXT_TO_FIT_SHAPE (normAutofit) is a PowerPoint-only rendering hint.
LibreOffice, Google Slides, and browser thumbnails ignore it entirely,
causing text to visually overflow below the slide boundary.

NONE (noAutofit) clips text at the explicit box height — combined with
genuinely-sized fonts it produces correct layout in all viewers.

Additional fixes:
- split_panel body: 13pt/6pt leading → 10pt/3pt leading (fits 28 lines)
- split_panel headline: 28pt → 26pt (more breathing room)
- Demo script headlines: shortened to fit within the 0.85" headline area
  without bleeding into the red rule line below
</commit_message>
<xml_diff>
--- a/Santander_Architecture.pptx
+++ b/Santander_Architecture.pptx
@@ -3459,7 +3459,7 @@
         </p:spPr>
         <p:txBody>
           <a:bodyPr wrap="square">
-            <a:normAutofit/>
+            <a:noAutofit/>
           </a:bodyPr>
           <a:lstStyle/>
           <a:p>
@@ -3772,7 +3772,7 @@
         </p:spPr>
         <p:txBody>
           <a:bodyPr wrap="square">
-            <a:normAutofit/>
+            <a:noAutofit/>
           </a:bodyPr>
           <a:lstStyle/>
           <a:p>
@@ -3875,7 +3875,7 @@
         </p:spPr>
         <p:txBody>
           <a:bodyPr wrap="square">
-            <a:normAutofit/>
+            <a:noAutofit/>
           </a:bodyPr>
           <a:lstStyle/>
           <a:p>
@@ -4167,7 +4167,7 @@
         </p:spPr>
         <p:txBody>
           <a:bodyPr wrap="square">
-            <a:normAutofit/>
+            <a:noAutofit/>
           </a:bodyPr>
           <a:lstStyle/>
           <a:p>
@@ -4464,7 +4464,7 @@
         </p:spPr>
         <p:txBody>
           <a:bodyPr wrap="square">
-            <a:normAutofit/>
+            <a:noAutofit/>
           </a:bodyPr>
           <a:lstStyle/>
           <a:p>
@@ -5706,7 +5706,7 @@
         </p:spPr>
         <p:txBody>
           <a:bodyPr wrap="square">
-            <a:normAutofit/>
+            <a:noAutofit/>
           </a:bodyPr>
           <a:lstStyle/>
           <a:p>
@@ -7048,7 +7048,7 @@
         </p:spPr>
         <p:txBody>
           <a:bodyPr wrap="square">
-            <a:normAutofit/>
+            <a:noAutofit/>
           </a:bodyPr>
           <a:lstStyle/>
           <a:p>
@@ -7153,7 +7153,7 @@
         </p:spPr>
         <p:txBody>
           <a:bodyPr wrap="square">
-            <a:normAutofit/>
+            <a:noAutofit/>
           </a:bodyPr>
           <a:lstStyle/>
           <a:p>

</xml_diff>

<commit_message>
Add INTERNAL · CONFIDENTIAL classification to all five decks
Professional polish for stakeholder meeting:
- Pitch deck: classification tag on cover + footer classification on every slide
- Project Record: cover tag + classification in dark footer bar
- Architecture: added full footer chrome (classification + credit + slide
  numbers) to all 12 slides — previously had none; cover tag
- Changes deck: classification + credit added to footer bar
- Walkthrough: classification footer on all content/two-col slides + cover tag

Every deck now carries standard internal-bank confidentiality marking.
All five rebuilt and verified to load.

Co-Authored-By: Claude Opus 4.8 <noreply@anthropic.com>
Claude-Session: https://claude.ai/code/session_012EFETGbhdxdnPCjpmQ9UDz
</commit_message>
<xml_diff>
--- a/Santander_Architecture.pptx
+++ b/Santander_Architecture.pptx
@@ -3295,6 +3295,84 @@
           </a:p>
         </p:txBody>
       </p:sp>
+      <p:sp>
+        <p:nvSpPr>
+          <p:cNvPr id="7" name="Rectangle 6"/>
+          <p:cNvSpPr/>
+          <p:nvPr/>
+        </p:nvSpPr>
+        <p:spPr>
+          <a:xfrm>
+            <a:off x="10012680" y="274320"/>
+            <a:ext cx="1783080" cy="310896"/>
+          </a:xfrm>
+          <a:prstGeom prst="rect">
+            <a:avLst/>
+          </a:prstGeom>
+          <a:solidFill>
+            <a:srgbClr val="C8102E"/>
+          </a:solidFill>
+          <a:ln>
+            <a:noFill/>
+          </a:ln>
+        </p:spPr>
+        <p:style>
+          <a:lnRef idx="1">
+            <a:schemeClr val="accent1"/>
+          </a:lnRef>
+          <a:fillRef idx="3">
+            <a:schemeClr val="accent1"/>
+          </a:fillRef>
+          <a:effectRef idx="2">
+            <a:schemeClr val="accent1"/>
+          </a:effectRef>
+          <a:fontRef idx="minor">
+            <a:schemeClr val="lt1"/>
+          </a:fontRef>
+        </p:style>
+        <p:txBody>
+          <a:bodyPr rtlCol="0" anchor="ctr"/>
+          <a:lstStyle/>
+          <a:p>
+            <a:pPr algn="ctr"/>
+          </a:p>
+        </p:txBody>
+      </p:sp>
+      <p:sp>
+        <p:nvSpPr>
+          <p:cNvPr id="8" name="TextBox 7"/>
+          <p:cNvSpPr txBox="1"/>
+          <p:nvPr/>
+        </p:nvSpPr>
+        <p:spPr>
+          <a:xfrm>
+            <a:off x="10012680" y="310896"/>
+            <a:ext cx="1783080" cy="237744"/>
+          </a:xfrm>
+          <a:prstGeom prst="rect">
+            <a:avLst/>
+          </a:prstGeom>
+          <a:noFill/>
+        </p:spPr>
+        <p:txBody>
+          <a:bodyPr wrap="square">
+            <a:spAutoFit/>
+          </a:bodyPr>
+          <a:lstStyle/>
+          <a:p>
+            <a:pPr algn="ctr"/>
+            <a:r>
+              <a:rPr sz="750" b="1" i="0">
+                <a:solidFill>
+                  <a:srgbClr val="FFFFFF"/>
+                </a:solidFill>
+                <a:latin typeface="Calibri"/>
+              </a:rPr>
+              <a:t>INTERNAL · CONFIDENTIAL</a:t>
+            </a:r>
+          </a:p>
+        </p:txBody>
+      </p:sp>
     </p:spTree>
   </p:cSld>
   <p:clrMapOvr>
@@ -3608,6 +3686,154 @@
           </a:p>
         </p:txBody>
       </p:sp>
+      <p:sp>
+        <p:nvSpPr>
+          <p:cNvPr id="6" name="Rectangle 5"/>
+          <p:cNvSpPr/>
+          <p:nvPr/>
+        </p:nvSpPr>
+        <p:spPr>
+          <a:xfrm>
+            <a:off x="0" y="6601968"/>
+            <a:ext cx="12188952" cy="256032"/>
+          </a:xfrm>
+          <a:prstGeom prst="rect">
+            <a:avLst/>
+          </a:prstGeom>
+          <a:solidFill>
+            <a:srgbClr val="1C1917"/>
+          </a:solidFill>
+          <a:ln>
+            <a:noFill/>
+          </a:ln>
+        </p:spPr>
+        <p:style>
+          <a:lnRef idx="1">
+            <a:schemeClr val="accent1"/>
+          </a:lnRef>
+          <a:fillRef idx="3">
+            <a:schemeClr val="accent1"/>
+          </a:fillRef>
+          <a:effectRef idx="2">
+            <a:schemeClr val="accent1"/>
+          </a:effectRef>
+          <a:fontRef idx="minor">
+            <a:schemeClr val="lt1"/>
+          </a:fontRef>
+        </p:style>
+        <p:txBody>
+          <a:bodyPr rtlCol="0" anchor="ctr"/>
+          <a:lstStyle/>
+          <a:p>
+            <a:pPr algn="ctr"/>
+          </a:p>
+        </p:txBody>
+      </p:sp>
+      <p:sp>
+        <p:nvSpPr>
+          <p:cNvPr id="7" name="TextBox 6"/>
+          <p:cNvSpPr txBox="1"/>
+          <p:nvPr/>
+        </p:nvSpPr>
+        <p:spPr>
+          <a:xfrm>
+            <a:off x="457200" y="6620256"/>
+            <a:ext cx="2743200" cy="201168"/>
+          </a:xfrm>
+          <a:prstGeom prst="rect">
+            <a:avLst/>
+          </a:prstGeom>
+          <a:noFill/>
+        </p:spPr>
+        <p:txBody>
+          <a:bodyPr wrap="square">
+            <a:spAutoFit/>
+          </a:bodyPr>
+          <a:lstStyle/>
+          <a:p>
+            <a:pPr algn="l"/>
+            <a:r>
+              <a:rPr sz="800" b="1" i="0">
+                <a:solidFill>
+                  <a:srgbClr val="FECACA"/>
+                </a:solidFill>
+                <a:latin typeface="Calibri"/>
+              </a:rPr>
+              <a:t>INTERNAL · CONFIDENTIAL</a:t>
+            </a:r>
+          </a:p>
+        </p:txBody>
+      </p:sp>
+      <p:sp>
+        <p:nvSpPr>
+          <p:cNvPr id="8" name="TextBox 7"/>
+          <p:cNvSpPr txBox="1"/>
+          <p:nvPr/>
+        </p:nvSpPr>
+        <p:spPr>
+          <a:xfrm>
+            <a:off x="3200400" y="6620256"/>
+            <a:ext cx="7863840" cy="201168"/>
+          </a:xfrm>
+          <a:prstGeom prst="rect">
+            <a:avLst/>
+          </a:prstGeom>
+          <a:noFill/>
+        </p:spPr>
+        <p:txBody>
+          <a:bodyPr wrap="square">
+            <a:spAutoFit/>
+          </a:bodyPr>
+          <a:lstStyle/>
+          <a:p>
+            <a:pPr algn="r"/>
+            <a:r>
+              <a:rPr sz="800" b="0" i="1">
+                <a:solidFill>
+                  <a:srgbClr val="D6D3D1"/>
+                </a:solidFill>
+                <a:latin typeface="Calibri"/>
+              </a:rPr>
+              <a:t>Alan Davidson · Business Banking Advisor · Self-initiated · Own time · June 2026</a:t>
+            </a:r>
+          </a:p>
+        </p:txBody>
+      </p:sp>
+      <p:sp>
+        <p:nvSpPr>
+          <p:cNvPr id="9" name="TextBox 8"/>
+          <p:cNvSpPr txBox="1"/>
+          <p:nvPr/>
+        </p:nvSpPr>
+        <p:spPr>
+          <a:xfrm>
+            <a:off x="11750040" y="6620256"/>
+            <a:ext cx="365760" cy="201168"/>
+          </a:xfrm>
+          <a:prstGeom prst="rect">
+            <a:avLst/>
+          </a:prstGeom>
+          <a:noFill/>
+        </p:spPr>
+        <p:txBody>
+          <a:bodyPr wrap="square">
+            <a:spAutoFit/>
+          </a:bodyPr>
+          <a:lstStyle/>
+          <a:p>
+            <a:pPr algn="r"/>
+            <a:r>
+              <a:rPr sz="800" b="0" i="0">
+                <a:solidFill>
+                  <a:srgbClr val="D6D3D1"/>
+                </a:solidFill>
+                <a:latin typeface="Calibri"/>
+              </a:rPr>
+              <a:t>10</a:t>
+            </a:r>
+          </a:p>
+        </p:txBody>
+      </p:sp>
     </p:spTree>
   </p:cSld>
   <p:clrMapOvr>
@@ -4003,6 +4229,154 @@
           </a:p>
         </p:txBody>
       </p:sp>
+      <p:sp>
+        <p:nvSpPr>
+          <p:cNvPr id="8" name="Rectangle 7"/>
+          <p:cNvSpPr/>
+          <p:nvPr/>
+        </p:nvSpPr>
+        <p:spPr>
+          <a:xfrm>
+            <a:off x="0" y="6601968"/>
+            <a:ext cx="12188952" cy="256032"/>
+          </a:xfrm>
+          <a:prstGeom prst="rect">
+            <a:avLst/>
+          </a:prstGeom>
+          <a:solidFill>
+            <a:srgbClr val="1C1917"/>
+          </a:solidFill>
+          <a:ln>
+            <a:noFill/>
+          </a:ln>
+        </p:spPr>
+        <p:style>
+          <a:lnRef idx="1">
+            <a:schemeClr val="accent1"/>
+          </a:lnRef>
+          <a:fillRef idx="3">
+            <a:schemeClr val="accent1"/>
+          </a:fillRef>
+          <a:effectRef idx="2">
+            <a:schemeClr val="accent1"/>
+          </a:effectRef>
+          <a:fontRef idx="minor">
+            <a:schemeClr val="lt1"/>
+          </a:fontRef>
+        </p:style>
+        <p:txBody>
+          <a:bodyPr rtlCol="0" anchor="ctr"/>
+          <a:lstStyle/>
+          <a:p>
+            <a:pPr algn="ctr"/>
+          </a:p>
+        </p:txBody>
+      </p:sp>
+      <p:sp>
+        <p:nvSpPr>
+          <p:cNvPr id="9" name="TextBox 8"/>
+          <p:cNvSpPr txBox="1"/>
+          <p:nvPr/>
+        </p:nvSpPr>
+        <p:spPr>
+          <a:xfrm>
+            <a:off x="457200" y="6620256"/>
+            <a:ext cx="2743200" cy="201168"/>
+          </a:xfrm>
+          <a:prstGeom prst="rect">
+            <a:avLst/>
+          </a:prstGeom>
+          <a:noFill/>
+        </p:spPr>
+        <p:txBody>
+          <a:bodyPr wrap="square">
+            <a:spAutoFit/>
+          </a:bodyPr>
+          <a:lstStyle/>
+          <a:p>
+            <a:pPr algn="l"/>
+            <a:r>
+              <a:rPr sz="800" b="1" i="0">
+                <a:solidFill>
+                  <a:srgbClr val="FECACA"/>
+                </a:solidFill>
+                <a:latin typeface="Calibri"/>
+              </a:rPr>
+              <a:t>INTERNAL · CONFIDENTIAL</a:t>
+            </a:r>
+          </a:p>
+        </p:txBody>
+      </p:sp>
+      <p:sp>
+        <p:nvSpPr>
+          <p:cNvPr id="10" name="TextBox 9"/>
+          <p:cNvSpPr txBox="1"/>
+          <p:nvPr/>
+        </p:nvSpPr>
+        <p:spPr>
+          <a:xfrm>
+            <a:off x="3200400" y="6620256"/>
+            <a:ext cx="7863840" cy="201168"/>
+          </a:xfrm>
+          <a:prstGeom prst="rect">
+            <a:avLst/>
+          </a:prstGeom>
+          <a:noFill/>
+        </p:spPr>
+        <p:txBody>
+          <a:bodyPr wrap="square">
+            <a:spAutoFit/>
+          </a:bodyPr>
+          <a:lstStyle/>
+          <a:p>
+            <a:pPr algn="r"/>
+            <a:r>
+              <a:rPr sz="800" b="0" i="1">
+                <a:solidFill>
+                  <a:srgbClr val="D6D3D1"/>
+                </a:solidFill>
+                <a:latin typeface="Calibri"/>
+              </a:rPr>
+              <a:t>Alan Davidson · Business Banking Advisor · Self-initiated · Own time · June 2026</a:t>
+            </a:r>
+          </a:p>
+        </p:txBody>
+      </p:sp>
+      <p:sp>
+        <p:nvSpPr>
+          <p:cNvPr id="11" name="TextBox 10"/>
+          <p:cNvSpPr txBox="1"/>
+          <p:nvPr/>
+        </p:nvSpPr>
+        <p:spPr>
+          <a:xfrm>
+            <a:off x="11750040" y="6620256"/>
+            <a:ext cx="365760" cy="201168"/>
+          </a:xfrm>
+          <a:prstGeom prst="rect">
+            <a:avLst/>
+          </a:prstGeom>
+          <a:noFill/>
+        </p:spPr>
+        <p:txBody>
+          <a:bodyPr wrap="square">
+            <a:spAutoFit/>
+          </a:bodyPr>
+          <a:lstStyle/>
+          <a:p>
+            <a:pPr algn="r"/>
+            <a:r>
+              <a:rPr sz="800" b="0" i="0">
+                <a:solidFill>
+                  <a:srgbClr val="D6D3D1"/>
+                </a:solidFill>
+                <a:latin typeface="Calibri"/>
+              </a:rPr>
+              <a:t>11</a:t>
+            </a:r>
+          </a:p>
+        </p:txBody>
+      </p:sp>
     </p:spTree>
   </p:cSld>
   <p:clrMapOvr>
@@ -4300,6 +4674,154 @@
           </a:p>
         </p:txBody>
       </p:sp>
+      <p:sp>
+        <p:nvSpPr>
+          <p:cNvPr id="6" name="Rectangle 5"/>
+          <p:cNvSpPr/>
+          <p:nvPr/>
+        </p:nvSpPr>
+        <p:spPr>
+          <a:xfrm>
+            <a:off x="0" y="6601968"/>
+            <a:ext cx="12188952" cy="256032"/>
+          </a:xfrm>
+          <a:prstGeom prst="rect">
+            <a:avLst/>
+          </a:prstGeom>
+          <a:solidFill>
+            <a:srgbClr val="1C1917"/>
+          </a:solidFill>
+          <a:ln>
+            <a:noFill/>
+          </a:ln>
+        </p:spPr>
+        <p:style>
+          <a:lnRef idx="1">
+            <a:schemeClr val="accent1"/>
+          </a:lnRef>
+          <a:fillRef idx="3">
+            <a:schemeClr val="accent1"/>
+          </a:fillRef>
+          <a:effectRef idx="2">
+            <a:schemeClr val="accent1"/>
+          </a:effectRef>
+          <a:fontRef idx="minor">
+            <a:schemeClr val="lt1"/>
+          </a:fontRef>
+        </p:style>
+        <p:txBody>
+          <a:bodyPr rtlCol="0" anchor="ctr"/>
+          <a:lstStyle/>
+          <a:p>
+            <a:pPr algn="ctr"/>
+          </a:p>
+        </p:txBody>
+      </p:sp>
+      <p:sp>
+        <p:nvSpPr>
+          <p:cNvPr id="7" name="TextBox 6"/>
+          <p:cNvSpPr txBox="1"/>
+          <p:nvPr/>
+        </p:nvSpPr>
+        <p:spPr>
+          <a:xfrm>
+            <a:off x="457200" y="6620256"/>
+            <a:ext cx="2743200" cy="201168"/>
+          </a:xfrm>
+          <a:prstGeom prst="rect">
+            <a:avLst/>
+          </a:prstGeom>
+          <a:noFill/>
+        </p:spPr>
+        <p:txBody>
+          <a:bodyPr wrap="square">
+            <a:spAutoFit/>
+          </a:bodyPr>
+          <a:lstStyle/>
+          <a:p>
+            <a:pPr algn="l"/>
+            <a:r>
+              <a:rPr sz="800" b="1" i="0">
+                <a:solidFill>
+                  <a:srgbClr val="FECACA"/>
+                </a:solidFill>
+                <a:latin typeface="Calibri"/>
+              </a:rPr>
+              <a:t>INTERNAL · CONFIDENTIAL</a:t>
+            </a:r>
+          </a:p>
+        </p:txBody>
+      </p:sp>
+      <p:sp>
+        <p:nvSpPr>
+          <p:cNvPr id="8" name="TextBox 7"/>
+          <p:cNvSpPr txBox="1"/>
+          <p:nvPr/>
+        </p:nvSpPr>
+        <p:spPr>
+          <a:xfrm>
+            <a:off x="3200400" y="6620256"/>
+            <a:ext cx="7863840" cy="201168"/>
+          </a:xfrm>
+          <a:prstGeom prst="rect">
+            <a:avLst/>
+          </a:prstGeom>
+          <a:noFill/>
+        </p:spPr>
+        <p:txBody>
+          <a:bodyPr wrap="square">
+            <a:spAutoFit/>
+          </a:bodyPr>
+          <a:lstStyle/>
+          <a:p>
+            <a:pPr algn="r"/>
+            <a:r>
+              <a:rPr sz="800" b="0" i="1">
+                <a:solidFill>
+                  <a:srgbClr val="D6D3D1"/>
+                </a:solidFill>
+                <a:latin typeface="Calibri"/>
+              </a:rPr>
+              <a:t>Alan Davidson · Business Banking Advisor · Self-initiated · Own time · June 2026</a:t>
+            </a:r>
+          </a:p>
+        </p:txBody>
+      </p:sp>
+      <p:sp>
+        <p:nvSpPr>
+          <p:cNvPr id="9" name="TextBox 8"/>
+          <p:cNvSpPr txBox="1"/>
+          <p:nvPr/>
+        </p:nvSpPr>
+        <p:spPr>
+          <a:xfrm>
+            <a:off x="11750040" y="6620256"/>
+            <a:ext cx="365760" cy="201168"/>
+          </a:xfrm>
+          <a:prstGeom prst="rect">
+            <a:avLst/>
+          </a:prstGeom>
+          <a:noFill/>
+        </p:spPr>
+        <p:txBody>
+          <a:bodyPr wrap="square">
+            <a:spAutoFit/>
+          </a:bodyPr>
+          <a:lstStyle/>
+          <a:p>
+            <a:pPr algn="r"/>
+            <a:r>
+              <a:rPr sz="800" b="0" i="0">
+                <a:solidFill>
+                  <a:srgbClr val="D6D3D1"/>
+                </a:solidFill>
+                <a:latin typeface="Calibri"/>
+              </a:rPr>
+              <a:t>12</a:t>
+            </a:r>
+          </a:p>
+        </p:txBody>
+      </p:sp>
     </p:spTree>
   </p:cSld>
   <p:clrMapOvr>
@@ -4581,6 +5103,154 @@
           </a:p>
         </p:txBody>
       </p:sp>
+      <p:sp>
+        <p:nvSpPr>
+          <p:cNvPr id="6" name="Rectangle 5"/>
+          <p:cNvSpPr/>
+          <p:nvPr/>
+        </p:nvSpPr>
+        <p:spPr>
+          <a:xfrm>
+            <a:off x="0" y="6601968"/>
+            <a:ext cx="12188952" cy="256032"/>
+          </a:xfrm>
+          <a:prstGeom prst="rect">
+            <a:avLst/>
+          </a:prstGeom>
+          <a:solidFill>
+            <a:srgbClr val="1C1917"/>
+          </a:solidFill>
+          <a:ln>
+            <a:noFill/>
+          </a:ln>
+        </p:spPr>
+        <p:style>
+          <a:lnRef idx="1">
+            <a:schemeClr val="accent1"/>
+          </a:lnRef>
+          <a:fillRef idx="3">
+            <a:schemeClr val="accent1"/>
+          </a:fillRef>
+          <a:effectRef idx="2">
+            <a:schemeClr val="accent1"/>
+          </a:effectRef>
+          <a:fontRef idx="minor">
+            <a:schemeClr val="lt1"/>
+          </a:fontRef>
+        </p:style>
+        <p:txBody>
+          <a:bodyPr rtlCol="0" anchor="ctr"/>
+          <a:lstStyle/>
+          <a:p>
+            <a:pPr algn="ctr"/>
+          </a:p>
+        </p:txBody>
+      </p:sp>
+      <p:sp>
+        <p:nvSpPr>
+          <p:cNvPr id="7" name="TextBox 6"/>
+          <p:cNvSpPr txBox="1"/>
+          <p:nvPr/>
+        </p:nvSpPr>
+        <p:spPr>
+          <a:xfrm>
+            <a:off x="457200" y="6620256"/>
+            <a:ext cx="2743200" cy="201168"/>
+          </a:xfrm>
+          <a:prstGeom prst="rect">
+            <a:avLst/>
+          </a:prstGeom>
+          <a:noFill/>
+        </p:spPr>
+        <p:txBody>
+          <a:bodyPr wrap="square">
+            <a:spAutoFit/>
+          </a:bodyPr>
+          <a:lstStyle/>
+          <a:p>
+            <a:pPr algn="l"/>
+            <a:r>
+              <a:rPr sz="800" b="1" i="0">
+                <a:solidFill>
+                  <a:srgbClr val="FECACA"/>
+                </a:solidFill>
+                <a:latin typeface="Calibri"/>
+              </a:rPr>
+              <a:t>INTERNAL · CONFIDENTIAL</a:t>
+            </a:r>
+          </a:p>
+        </p:txBody>
+      </p:sp>
+      <p:sp>
+        <p:nvSpPr>
+          <p:cNvPr id="8" name="TextBox 7"/>
+          <p:cNvSpPr txBox="1"/>
+          <p:nvPr/>
+        </p:nvSpPr>
+        <p:spPr>
+          <a:xfrm>
+            <a:off x="3200400" y="6620256"/>
+            <a:ext cx="7863840" cy="201168"/>
+          </a:xfrm>
+          <a:prstGeom prst="rect">
+            <a:avLst/>
+          </a:prstGeom>
+          <a:noFill/>
+        </p:spPr>
+        <p:txBody>
+          <a:bodyPr wrap="square">
+            <a:spAutoFit/>
+          </a:bodyPr>
+          <a:lstStyle/>
+          <a:p>
+            <a:pPr algn="r"/>
+            <a:r>
+              <a:rPr sz="800" b="0" i="1">
+                <a:solidFill>
+                  <a:srgbClr val="D6D3D1"/>
+                </a:solidFill>
+                <a:latin typeface="Calibri"/>
+              </a:rPr>
+              <a:t>Alan Davidson · Business Banking Advisor · Self-initiated · Own time · June 2026</a:t>
+            </a:r>
+          </a:p>
+        </p:txBody>
+      </p:sp>
+      <p:sp>
+        <p:nvSpPr>
+          <p:cNvPr id="9" name="TextBox 8"/>
+          <p:cNvSpPr txBox="1"/>
+          <p:nvPr/>
+        </p:nvSpPr>
+        <p:spPr>
+          <a:xfrm>
+            <a:off x="11750040" y="6620256"/>
+            <a:ext cx="365760" cy="201168"/>
+          </a:xfrm>
+          <a:prstGeom prst="rect">
+            <a:avLst/>
+          </a:prstGeom>
+          <a:noFill/>
+        </p:spPr>
+        <p:txBody>
+          <a:bodyPr wrap="square">
+            <a:spAutoFit/>
+          </a:bodyPr>
+          <a:lstStyle/>
+          <a:p>
+            <a:pPr algn="r"/>
+            <a:r>
+              <a:rPr sz="800" b="0" i="0">
+                <a:solidFill>
+                  <a:srgbClr val="D6D3D1"/>
+                </a:solidFill>
+                <a:latin typeface="Calibri"/>
+              </a:rPr>
+              <a:t>2</a:t>
+            </a:r>
+          </a:p>
+        </p:txBody>
+      </p:sp>
     </p:spTree>
   </p:cSld>
   <p:clrMapOvr>
@@ -5542,6 +6212,154 @@
           </a:p>
         </p:txBody>
       </p:sp>
+      <p:sp>
+        <p:nvSpPr>
+          <p:cNvPr id="29" name="Rectangle 28"/>
+          <p:cNvSpPr/>
+          <p:nvPr/>
+        </p:nvSpPr>
+        <p:spPr>
+          <a:xfrm>
+            <a:off x="0" y="6601968"/>
+            <a:ext cx="12188952" cy="256032"/>
+          </a:xfrm>
+          <a:prstGeom prst="rect">
+            <a:avLst/>
+          </a:prstGeom>
+          <a:solidFill>
+            <a:srgbClr val="1C1917"/>
+          </a:solidFill>
+          <a:ln>
+            <a:noFill/>
+          </a:ln>
+        </p:spPr>
+        <p:style>
+          <a:lnRef idx="1">
+            <a:schemeClr val="accent1"/>
+          </a:lnRef>
+          <a:fillRef idx="3">
+            <a:schemeClr val="accent1"/>
+          </a:fillRef>
+          <a:effectRef idx="2">
+            <a:schemeClr val="accent1"/>
+          </a:effectRef>
+          <a:fontRef idx="minor">
+            <a:schemeClr val="lt1"/>
+          </a:fontRef>
+        </p:style>
+        <p:txBody>
+          <a:bodyPr rtlCol="0" anchor="ctr"/>
+          <a:lstStyle/>
+          <a:p>
+            <a:pPr algn="ctr"/>
+          </a:p>
+        </p:txBody>
+      </p:sp>
+      <p:sp>
+        <p:nvSpPr>
+          <p:cNvPr id="30" name="TextBox 29"/>
+          <p:cNvSpPr txBox="1"/>
+          <p:nvPr/>
+        </p:nvSpPr>
+        <p:spPr>
+          <a:xfrm>
+            <a:off x="457200" y="6620256"/>
+            <a:ext cx="2743200" cy="201168"/>
+          </a:xfrm>
+          <a:prstGeom prst="rect">
+            <a:avLst/>
+          </a:prstGeom>
+          <a:noFill/>
+        </p:spPr>
+        <p:txBody>
+          <a:bodyPr wrap="square">
+            <a:spAutoFit/>
+          </a:bodyPr>
+          <a:lstStyle/>
+          <a:p>
+            <a:pPr algn="l"/>
+            <a:r>
+              <a:rPr sz="800" b="1" i="0">
+                <a:solidFill>
+                  <a:srgbClr val="FECACA"/>
+                </a:solidFill>
+                <a:latin typeface="Calibri"/>
+              </a:rPr>
+              <a:t>INTERNAL · CONFIDENTIAL</a:t>
+            </a:r>
+          </a:p>
+        </p:txBody>
+      </p:sp>
+      <p:sp>
+        <p:nvSpPr>
+          <p:cNvPr id="31" name="TextBox 30"/>
+          <p:cNvSpPr txBox="1"/>
+          <p:nvPr/>
+        </p:nvSpPr>
+        <p:spPr>
+          <a:xfrm>
+            <a:off x="3200400" y="6620256"/>
+            <a:ext cx="7863840" cy="201168"/>
+          </a:xfrm>
+          <a:prstGeom prst="rect">
+            <a:avLst/>
+          </a:prstGeom>
+          <a:noFill/>
+        </p:spPr>
+        <p:txBody>
+          <a:bodyPr wrap="square">
+            <a:spAutoFit/>
+          </a:bodyPr>
+          <a:lstStyle/>
+          <a:p>
+            <a:pPr algn="r"/>
+            <a:r>
+              <a:rPr sz="800" b="0" i="1">
+                <a:solidFill>
+                  <a:srgbClr val="D6D3D1"/>
+                </a:solidFill>
+                <a:latin typeface="Calibri"/>
+              </a:rPr>
+              <a:t>Alan Davidson · Business Banking Advisor · Self-initiated · Own time · June 2026</a:t>
+            </a:r>
+          </a:p>
+        </p:txBody>
+      </p:sp>
+      <p:sp>
+        <p:nvSpPr>
+          <p:cNvPr id="32" name="TextBox 31"/>
+          <p:cNvSpPr txBox="1"/>
+          <p:nvPr/>
+        </p:nvSpPr>
+        <p:spPr>
+          <a:xfrm>
+            <a:off x="11750040" y="6620256"/>
+            <a:ext cx="365760" cy="201168"/>
+          </a:xfrm>
+          <a:prstGeom prst="rect">
+            <a:avLst/>
+          </a:prstGeom>
+          <a:noFill/>
+        </p:spPr>
+        <p:txBody>
+          <a:bodyPr wrap="square">
+            <a:spAutoFit/>
+          </a:bodyPr>
+          <a:lstStyle/>
+          <a:p>
+            <a:pPr algn="r"/>
+            <a:r>
+              <a:rPr sz="800" b="0" i="0">
+                <a:solidFill>
+                  <a:srgbClr val="D6D3D1"/>
+                </a:solidFill>
+                <a:latin typeface="Calibri"/>
+              </a:rPr>
+              <a:t>3</a:t>
+            </a:r>
+          </a:p>
+        </p:txBody>
+      </p:sp>
     </p:spTree>
   </p:cSld>
   <p:clrMapOvr>
@@ -5807,6 +6625,154 @@
           </a:p>
         </p:txBody>
       </p:sp>
+      <p:sp>
+        <p:nvSpPr>
+          <p:cNvPr id="6" name="Rectangle 5"/>
+          <p:cNvSpPr/>
+          <p:nvPr/>
+        </p:nvSpPr>
+        <p:spPr>
+          <a:xfrm>
+            <a:off x="0" y="6601968"/>
+            <a:ext cx="12188952" cy="256032"/>
+          </a:xfrm>
+          <a:prstGeom prst="rect">
+            <a:avLst/>
+          </a:prstGeom>
+          <a:solidFill>
+            <a:srgbClr val="1C1917"/>
+          </a:solidFill>
+          <a:ln>
+            <a:noFill/>
+          </a:ln>
+        </p:spPr>
+        <p:style>
+          <a:lnRef idx="1">
+            <a:schemeClr val="accent1"/>
+          </a:lnRef>
+          <a:fillRef idx="3">
+            <a:schemeClr val="accent1"/>
+          </a:fillRef>
+          <a:effectRef idx="2">
+            <a:schemeClr val="accent1"/>
+          </a:effectRef>
+          <a:fontRef idx="minor">
+            <a:schemeClr val="lt1"/>
+          </a:fontRef>
+        </p:style>
+        <p:txBody>
+          <a:bodyPr rtlCol="0" anchor="ctr"/>
+          <a:lstStyle/>
+          <a:p>
+            <a:pPr algn="ctr"/>
+          </a:p>
+        </p:txBody>
+      </p:sp>
+      <p:sp>
+        <p:nvSpPr>
+          <p:cNvPr id="7" name="TextBox 6"/>
+          <p:cNvSpPr txBox="1"/>
+          <p:nvPr/>
+        </p:nvSpPr>
+        <p:spPr>
+          <a:xfrm>
+            <a:off x="457200" y="6620256"/>
+            <a:ext cx="2743200" cy="201168"/>
+          </a:xfrm>
+          <a:prstGeom prst="rect">
+            <a:avLst/>
+          </a:prstGeom>
+          <a:noFill/>
+        </p:spPr>
+        <p:txBody>
+          <a:bodyPr wrap="square">
+            <a:spAutoFit/>
+          </a:bodyPr>
+          <a:lstStyle/>
+          <a:p>
+            <a:pPr algn="l"/>
+            <a:r>
+              <a:rPr sz="800" b="1" i="0">
+                <a:solidFill>
+                  <a:srgbClr val="FECACA"/>
+                </a:solidFill>
+                <a:latin typeface="Calibri"/>
+              </a:rPr>
+              <a:t>INTERNAL · CONFIDENTIAL</a:t>
+            </a:r>
+          </a:p>
+        </p:txBody>
+      </p:sp>
+      <p:sp>
+        <p:nvSpPr>
+          <p:cNvPr id="8" name="TextBox 7"/>
+          <p:cNvSpPr txBox="1"/>
+          <p:nvPr/>
+        </p:nvSpPr>
+        <p:spPr>
+          <a:xfrm>
+            <a:off x="3200400" y="6620256"/>
+            <a:ext cx="7863840" cy="201168"/>
+          </a:xfrm>
+          <a:prstGeom prst="rect">
+            <a:avLst/>
+          </a:prstGeom>
+          <a:noFill/>
+        </p:spPr>
+        <p:txBody>
+          <a:bodyPr wrap="square">
+            <a:spAutoFit/>
+          </a:bodyPr>
+          <a:lstStyle/>
+          <a:p>
+            <a:pPr algn="r"/>
+            <a:r>
+              <a:rPr sz="800" b="0" i="1">
+                <a:solidFill>
+                  <a:srgbClr val="D6D3D1"/>
+                </a:solidFill>
+                <a:latin typeface="Calibri"/>
+              </a:rPr>
+              <a:t>Alan Davidson · Business Banking Advisor · Self-initiated · Own time · June 2026</a:t>
+            </a:r>
+          </a:p>
+        </p:txBody>
+      </p:sp>
+      <p:sp>
+        <p:nvSpPr>
+          <p:cNvPr id="9" name="TextBox 8"/>
+          <p:cNvSpPr txBox="1"/>
+          <p:nvPr/>
+        </p:nvSpPr>
+        <p:spPr>
+          <a:xfrm>
+            <a:off x="11750040" y="6620256"/>
+            <a:ext cx="365760" cy="201168"/>
+          </a:xfrm>
+          <a:prstGeom prst="rect">
+            <a:avLst/>
+          </a:prstGeom>
+          <a:noFill/>
+        </p:spPr>
+        <p:txBody>
+          <a:bodyPr wrap="square">
+            <a:spAutoFit/>
+          </a:bodyPr>
+          <a:lstStyle/>
+          <a:p>
+            <a:pPr algn="r"/>
+            <a:r>
+              <a:rPr sz="800" b="0" i="0">
+                <a:solidFill>
+                  <a:srgbClr val="D6D3D1"/>
+                </a:solidFill>
+                <a:latin typeface="Calibri"/>
+              </a:rPr>
+              <a:t>4</a:t>
+            </a:r>
+          </a:p>
+        </p:txBody>
+      </p:sp>
     </p:spTree>
   </p:cSld>
   <p:clrMapOvr>
@@ -6288,6 +7254,154 @@
           </a:p>
         </p:txBody>
       </p:sp>
+      <p:sp>
+        <p:nvSpPr>
+          <p:cNvPr id="7" name="Rectangle 6"/>
+          <p:cNvSpPr/>
+          <p:nvPr/>
+        </p:nvSpPr>
+        <p:spPr>
+          <a:xfrm>
+            <a:off x="0" y="6601968"/>
+            <a:ext cx="12188952" cy="256032"/>
+          </a:xfrm>
+          <a:prstGeom prst="rect">
+            <a:avLst/>
+          </a:prstGeom>
+          <a:solidFill>
+            <a:srgbClr val="1C1917"/>
+          </a:solidFill>
+          <a:ln>
+            <a:noFill/>
+          </a:ln>
+        </p:spPr>
+        <p:style>
+          <a:lnRef idx="1">
+            <a:schemeClr val="accent1"/>
+          </a:lnRef>
+          <a:fillRef idx="3">
+            <a:schemeClr val="accent1"/>
+          </a:fillRef>
+          <a:effectRef idx="2">
+            <a:schemeClr val="accent1"/>
+          </a:effectRef>
+          <a:fontRef idx="minor">
+            <a:schemeClr val="lt1"/>
+          </a:fontRef>
+        </p:style>
+        <p:txBody>
+          <a:bodyPr rtlCol="0" anchor="ctr"/>
+          <a:lstStyle/>
+          <a:p>
+            <a:pPr algn="ctr"/>
+          </a:p>
+        </p:txBody>
+      </p:sp>
+      <p:sp>
+        <p:nvSpPr>
+          <p:cNvPr id="8" name="TextBox 7"/>
+          <p:cNvSpPr txBox="1"/>
+          <p:nvPr/>
+        </p:nvSpPr>
+        <p:spPr>
+          <a:xfrm>
+            <a:off x="457200" y="6620256"/>
+            <a:ext cx="2743200" cy="201168"/>
+          </a:xfrm>
+          <a:prstGeom prst="rect">
+            <a:avLst/>
+          </a:prstGeom>
+          <a:noFill/>
+        </p:spPr>
+        <p:txBody>
+          <a:bodyPr wrap="square">
+            <a:spAutoFit/>
+          </a:bodyPr>
+          <a:lstStyle/>
+          <a:p>
+            <a:pPr algn="l"/>
+            <a:r>
+              <a:rPr sz="800" b="1" i="0">
+                <a:solidFill>
+                  <a:srgbClr val="FECACA"/>
+                </a:solidFill>
+                <a:latin typeface="Calibri"/>
+              </a:rPr>
+              <a:t>INTERNAL · CONFIDENTIAL</a:t>
+            </a:r>
+          </a:p>
+        </p:txBody>
+      </p:sp>
+      <p:sp>
+        <p:nvSpPr>
+          <p:cNvPr id="9" name="TextBox 8"/>
+          <p:cNvSpPr txBox="1"/>
+          <p:nvPr/>
+        </p:nvSpPr>
+        <p:spPr>
+          <a:xfrm>
+            <a:off x="3200400" y="6620256"/>
+            <a:ext cx="7863840" cy="201168"/>
+          </a:xfrm>
+          <a:prstGeom prst="rect">
+            <a:avLst/>
+          </a:prstGeom>
+          <a:noFill/>
+        </p:spPr>
+        <p:txBody>
+          <a:bodyPr wrap="square">
+            <a:spAutoFit/>
+          </a:bodyPr>
+          <a:lstStyle/>
+          <a:p>
+            <a:pPr algn="r"/>
+            <a:r>
+              <a:rPr sz="800" b="0" i="1">
+                <a:solidFill>
+                  <a:srgbClr val="D6D3D1"/>
+                </a:solidFill>
+                <a:latin typeface="Calibri"/>
+              </a:rPr>
+              <a:t>Alan Davidson · Business Banking Advisor · Self-initiated · Own time · June 2026</a:t>
+            </a:r>
+          </a:p>
+        </p:txBody>
+      </p:sp>
+      <p:sp>
+        <p:nvSpPr>
+          <p:cNvPr id="10" name="TextBox 9"/>
+          <p:cNvSpPr txBox="1"/>
+          <p:nvPr/>
+        </p:nvSpPr>
+        <p:spPr>
+          <a:xfrm>
+            <a:off x="11750040" y="6620256"/>
+            <a:ext cx="365760" cy="201168"/>
+          </a:xfrm>
+          <a:prstGeom prst="rect">
+            <a:avLst/>
+          </a:prstGeom>
+          <a:noFill/>
+        </p:spPr>
+        <p:txBody>
+          <a:bodyPr wrap="square">
+            <a:spAutoFit/>
+          </a:bodyPr>
+          <a:lstStyle/>
+          <a:p>
+            <a:pPr algn="r"/>
+            <a:r>
+              <a:rPr sz="800" b="0" i="0">
+                <a:solidFill>
+                  <a:srgbClr val="D6D3D1"/>
+                </a:solidFill>
+                <a:latin typeface="Calibri"/>
+              </a:rPr>
+              <a:t>5</a:t>
+            </a:r>
+          </a:p>
+        </p:txBody>
+      </p:sp>
     </p:spTree>
   </p:cSld>
   <p:clrMapOvr>
@@ -6569,6 +7683,154 @@
           </a:p>
         </p:txBody>
       </p:sp>
+      <p:sp>
+        <p:nvSpPr>
+          <p:cNvPr id="6" name="Rectangle 5"/>
+          <p:cNvSpPr/>
+          <p:nvPr/>
+        </p:nvSpPr>
+        <p:spPr>
+          <a:xfrm>
+            <a:off x="0" y="6601968"/>
+            <a:ext cx="12188952" cy="256032"/>
+          </a:xfrm>
+          <a:prstGeom prst="rect">
+            <a:avLst/>
+          </a:prstGeom>
+          <a:solidFill>
+            <a:srgbClr val="1C1917"/>
+          </a:solidFill>
+          <a:ln>
+            <a:noFill/>
+          </a:ln>
+        </p:spPr>
+        <p:style>
+          <a:lnRef idx="1">
+            <a:schemeClr val="accent1"/>
+          </a:lnRef>
+          <a:fillRef idx="3">
+            <a:schemeClr val="accent1"/>
+          </a:fillRef>
+          <a:effectRef idx="2">
+            <a:schemeClr val="accent1"/>
+          </a:effectRef>
+          <a:fontRef idx="minor">
+            <a:schemeClr val="lt1"/>
+          </a:fontRef>
+        </p:style>
+        <p:txBody>
+          <a:bodyPr rtlCol="0" anchor="ctr"/>
+          <a:lstStyle/>
+          <a:p>
+            <a:pPr algn="ctr"/>
+          </a:p>
+        </p:txBody>
+      </p:sp>
+      <p:sp>
+        <p:nvSpPr>
+          <p:cNvPr id="7" name="TextBox 6"/>
+          <p:cNvSpPr txBox="1"/>
+          <p:nvPr/>
+        </p:nvSpPr>
+        <p:spPr>
+          <a:xfrm>
+            <a:off x="457200" y="6620256"/>
+            <a:ext cx="2743200" cy="201168"/>
+          </a:xfrm>
+          <a:prstGeom prst="rect">
+            <a:avLst/>
+          </a:prstGeom>
+          <a:noFill/>
+        </p:spPr>
+        <p:txBody>
+          <a:bodyPr wrap="square">
+            <a:spAutoFit/>
+          </a:bodyPr>
+          <a:lstStyle/>
+          <a:p>
+            <a:pPr algn="l"/>
+            <a:r>
+              <a:rPr sz="800" b="1" i="0">
+                <a:solidFill>
+                  <a:srgbClr val="FECACA"/>
+                </a:solidFill>
+                <a:latin typeface="Calibri"/>
+              </a:rPr>
+              <a:t>INTERNAL · CONFIDENTIAL</a:t>
+            </a:r>
+          </a:p>
+        </p:txBody>
+      </p:sp>
+      <p:sp>
+        <p:nvSpPr>
+          <p:cNvPr id="8" name="TextBox 7"/>
+          <p:cNvSpPr txBox="1"/>
+          <p:nvPr/>
+        </p:nvSpPr>
+        <p:spPr>
+          <a:xfrm>
+            <a:off x="3200400" y="6620256"/>
+            <a:ext cx="7863840" cy="201168"/>
+          </a:xfrm>
+          <a:prstGeom prst="rect">
+            <a:avLst/>
+          </a:prstGeom>
+          <a:noFill/>
+        </p:spPr>
+        <p:txBody>
+          <a:bodyPr wrap="square">
+            <a:spAutoFit/>
+          </a:bodyPr>
+          <a:lstStyle/>
+          <a:p>
+            <a:pPr algn="r"/>
+            <a:r>
+              <a:rPr sz="800" b="0" i="1">
+                <a:solidFill>
+                  <a:srgbClr val="D6D3D1"/>
+                </a:solidFill>
+                <a:latin typeface="Calibri"/>
+              </a:rPr>
+              <a:t>Alan Davidson · Business Banking Advisor · Self-initiated · Own time · June 2026</a:t>
+            </a:r>
+          </a:p>
+        </p:txBody>
+      </p:sp>
+      <p:sp>
+        <p:nvSpPr>
+          <p:cNvPr id="9" name="TextBox 8"/>
+          <p:cNvSpPr txBox="1"/>
+          <p:nvPr/>
+        </p:nvSpPr>
+        <p:spPr>
+          <a:xfrm>
+            <a:off x="11750040" y="6620256"/>
+            <a:ext cx="365760" cy="201168"/>
+          </a:xfrm>
+          <a:prstGeom prst="rect">
+            <a:avLst/>
+          </a:prstGeom>
+          <a:noFill/>
+        </p:spPr>
+        <p:txBody>
+          <a:bodyPr wrap="square">
+            <a:spAutoFit/>
+          </a:bodyPr>
+          <a:lstStyle/>
+          <a:p>
+            <a:pPr algn="r"/>
+            <a:r>
+              <a:rPr sz="800" b="0" i="0">
+                <a:solidFill>
+                  <a:srgbClr val="D6D3D1"/>
+                </a:solidFill>
+                <a:latin typeface="Calibri"/>
+              </a:rPr>
+              <a:t>6</a:t>
+            </a:r>
+          </a:p>
+        </p:txBody>
+      </p:sp>
     </p:spTree>
   </p:cSld>
   <p:clrMapOvr>
@@ -6850,6 +8112,154 @@
           </a:p>
         </p:txBody>
       </p:sp>
+      <p:sp>
+        <p:nvSpPr>
+          <p:cNvPr id="6" name="Rectangle 5"/>
+          <p:cNvSpPr/>
+          <p:nvPr/>
+        </p:nvSpPr>
+        <p:spPr>
+          <a:xfrm>
+            <a:off x="0" y="6601968"/>
+            <a:ext cx="12188952" cy="256032"/>
+          </a:xfrm>
+          <a:prstGeom prst="rect">
+            <a:avLst/>
+          </a:prstGeom>
+          <a:solidFill>
+            <a:srgbClr val="1C1917"/>
+          </a:solidFill>
+          <a:ln>
+            <a:noFill/>
+          </a:ln>
+        </p:spPr>
+        <p:style>
+          <a:lnRef idx="1">
+            <a:schemeClr val="accent1"/>
+          </a:lnRef>
+          <a:fillRef idx="3">
+            <a:schemeClr val="accent1"/>
+          </a:fillRef>
+          <a:effectRef idx="2">
+            <a:schemeClr val="accent1"/>
+          </a:effectRef>
+          <a:fontRef idx="minor">
+            <a:schemeClr val="lt1"/>
+          </a:fontRef>
+        </p:style>
+        <p:txBody>
+          <a:bodyPr rtlCol="0" anchor="ctr"/>
+          <a:lstStyle/>
+          <a:p>
+            <a:pPr algn="ctr"/>
+          </a:p>
+        </p:txBody>
+      </p:sp>
+      <p:sp>
+        <p:nvSpPr>
+          <p:cNvPr id="7" name="TextBox 6"/>
+          <p:cNvSpPr txBox="1"/>
+          <p:nvPr/>
+        </p:nvSpPr>
+        <p:spPr>
+          <a:xfrm>
+            <a:off x="457200" y="6620256"/>
+            <a:ext cx="2743200" cy="201168"/>
+          </a:xfrm>
+          <a:prstGeom prst="rect">
+            <a:avLst/>
+          </a:prstGeom>
+          <a:noFill/>
+        </p:spPr>
+        <p:txBody>
+          <a:bodyPr wrap="square">
+            <a:spAutoFit/>
+          </a:bodyPr>
+          <a:lstStyle/>
+          <a:p>
+            <a:pPr algn="l"/>
+            <a:r>
+              <a:rPr sz="800" b="1" i="0">
+                <a:solidFill>
+                  <a:srgbClr val="FECACA"/>
+                </a:solidFill>
+                <a:latin typeface="Calibri"/>
+              </a:rPr>
+              <a:t>INTERNAL · CONFIDENTIAL</a:t>
+            </a:r>
+          </a:p>
+        </p:txBody>
+      </p:sp>
+      <p:sp>
+        <p:nvSpPr>
+          <p:cNvPr id="8" name="TextBox 7"/>
+          <p:cNvSpPr txBox="1"/>
+          <p:nvPr/>
+        </p:nvSpPr>
+        <p:spPr>
+          <a:xfrm>
+            <a:off x="3200400" y="6620256"/>
+            <a:ext cx="7863840" cy="201168"/>
+          </a:xfrm>
+          <a:prstGeom prst="rect">
+            <a:avLst/>
+          </a:prstGeom>
+          <a:noFill/>
+        </p:spPr>
+        <p:txBody>
+          <a:bodyPr wrap="square">
+            <a:spAutoFit/>
+          </a:bodyPr>
+          <a:lstStyle/>
+          <a:p>
+            <a:pPr algn="r"/>
+            <a:r>
+              <a:rPr sz="800" b="0" i="1">
+                <a:solidFill>
+                  <a:srgbClr val="D6D3D1"/>
+                </a:solidFill>
+                <a:latin typeface="Calibri"/>
+              </a:rPr>
+              <a:t>Alan Davidson · Business Banking Advisor · Self-initiated · Own time · June 2026</a:t>
+            </a:r>
+          </a:p>
+        </p:txBody>
+      </p:sp>
+      <p:sp>
+        <p:nvSpPr>
+          <p:cNvPr id="9" name="TextBox 8"/>
+          <p:cNvSpPr txBox="1"/>
+          <p:nvPr/>
+        </p:nvSpPr>
+        <p:spPr>
+          <a:xfrm>
+            <a:off x="11750040" y="6620256"/>
+            <a:ext cx="365760" cy="201168"/>
+          </a:xfrm>
+          <a:prstGeom prst="rect">
+            <a:avLst/>
+          </a:prstGeom>
+          <a:noFill/>
+        </p:spPr>
+        <p:txBody>
+          <a:bodyPr wrap="square">
+            <a:spAutoFit/>
+          </a:bodyPr>
+          <a:lstStyle/>
+          <a:p>
+            <a:pPr algn="r"/>
+            <a:r>
+              <a:rPr sz="800" b="0" i="0">
+                <a:solidFill>
+                  <a:srgbClr val="D6D3D1"/>
+                </a:solidFill>
+                <a:latin typeface="Calibri"/>
+              </a:rPr>
+              <a:t>7</a:t>
+            </a:r>
+          </a:p>
+        </p:txBody>
+      </p:sp>
     </p:spTree>
   </p:cSld>
   <p:clrMapOvr>
@@ -7265,6 +8675,154 @@
           </a:p>
         </p:txBody>
       </p:sp>
+      <p:sp>
+        <p:nvSpPr>
+          <p:cNvPr id="10" name="Rectangle 9"/>
+          <p:cNvSpPr/>
+          <p:nvPr/>
+        </p:nvSpPr>
+        <p:spPr>
+          <a:xfrm>
+            <a:off x="0" y="6601968"/>
+            <a:ext cx="12188952" cy="256032"/>
+          </a:xfrm>
+          <a:prstGeom prst="rect">
+            <a:avLst/>
+          </a:prstGeom>
+          <a:solidFill>
+            <a:srgbClr val="1C1917"/>
+          </a:solidFill>
+          <a:ln>
+            <a:noFill/>
+          </a:ln>
+        </p:spPr>
+        <p:style>
+          <a:lnRef idx="1">
+            <a:schemeClr val="accent1"/>
+          </a:lnRef>
+          <a:fillRef idx="3">
+            <a:schemeClr val="accent1"/>
+          </a:fillRef>
+          <a:effectRef idx="2">
+            <a:schemeClr val="accent1"/>
+          </a:effectRef>
+          <a:fontRef idx="minor">
+            <a:schemeClr val="lt1"/>
+          </a:fontRef>
+        </p:style>
+        <p:txBody>
+          <a:bodyPr rtlCol="0" anchor="ctr"/>
+          <a:lstStyle/>
+          <a:p>
+            <a:pPr algn="ctr"/>
+          </a:p>
+        </p:txBody>
+      </p:sp>
+      <p:sp>
+        <p:nvSpPr>
+          <p:cNvPr id="11" name="TextBox 10"/>
+          <p:cNvSpPr txBox="1"/>
+          <p:nvPr/>
+        </p:nvSpPr>
+        <p:spPr>
+          <a:xfrm>
+            <a:off x="457200" y="6620256"/>
+            <a:ext cx="2743200" cy="201168"/>
+          </a:xfrm>
+          <a:prstGeom prst="rect">
+            <a:avLst/>
+          </a:prstGeom>
+          <a:noFill/>
+        </p:spPr>
+        <p:txBody>
+          <a:bodyPr wrap="square">
+            <a:spAutoFit/>
+          </a:bodyPr>
+          <a:lstStyle/>
+          <a:p>
+            <a:pPr algn="l"/>
+            <a:r>
+              <a:rPr sz="800" b="1" i="0">
+                <a:solidFill>
+                  <a:srgbClr val="FECACA"/>
+                </a:solidFill>
+                <a:latin typeface="Calibri"/>
+              </a:rPr>
+              <a:t>INTERNAL · CONFIDENTIAL</a:t>
+            </a:r>
+          </a:p>
+        </p:txBody>
+      </p:sp>
+      <p:sp>
+        <p:nvSpPr>
+          <p:cNvPr id="12" name="TextBox 11"/>
+          <p:cNvSpPr txBox="1"/>
+          <p:nvPr/>
+        </p:nvSpPr>
+        <p:spPr>
+          <a:xfrm>
+            <a:off x="3200400" y="6620256"/>
+            <a:ext cx="7863840" cy="201168"/>
+          </a:xfrm>
+          <a:prstGeom prst="rect">
+            <a:avLst/>
+          </a:prstGeom>
+          <a:noFill/>
+        </p:spPr>
+        <p:txBody>
+          <a:bodyPr wrap="square">
+            <a:spAutoFit/>
+          </a:bodyPr>
+          <a:lstStyle/>
+          <a:p>
+            <a:pPr algn="r"/>
+            <a:r>
+              <a:rPr sz="800" b="0" i="1">
+                <a:solidFill>
+                  <a:srgbClr val="D6D3D1"/>
+                </a:solidFill>
+                <a:latin typeface="Calibri"/>
+              </a:rPr>
+              <a:t>Alan Davidson · Business Banking Advisor · Self-initiated · Own time · June 2026</a:t>
+            </a:r>
+          </a:p>
+        </p:txBody>
+      </p:sp>
+      <p:sp>
+        <p:nvSpPr>
+          <p:cNvPr id="13" name="TextBox 12"/>
+          <p:cNvSpPr txBox="1"/>
+          <p:nvPr/>
+        </p:nvSpPr>
+        <p:spPr>
+          <a:xfrm>
+            <a:off x="11750040" y="6620256"/>
+            <a:ext cx="365760" cy="201168"/>
+          </a:xfrm>
+          <a:prstGeom prst="rect">
+            <a:avLst/>
+          </a:prstGeom>
+          <a:noFill/>
+        </p:spPr>
+        <p:txBody>
+          <a:bodyPr wrap="square">
+            <a:spAutoFit/>
+          </a:bodyPr>
+          <a:lstStyle/>
+          <a:p>
+            <a:pPr algn="r"/>
+            <a:r>
+              <a:rPr sz="800" b="0" i="0">
+                <a:solidFill>
+                  <a:srgbClr val="D6D3D1"/>
+                </a:solidFill>
+                <a:latin typeface="Calibri"/>
+              </a:rPr>
+              <a:t>8</a:t>
+            </a:r>
+          </a:p>
+        </p:txBody>
+      </p:sp>
     </p:spTree>
   </p:cSld>
   <p:clrMapOvr>
@@ -7622,6 +9180,154 @@
                 <a:latin typeface="Calibri"/>
               </a:rPr>
               <a:t>• renderMtdSubmit (~4998) — Making Tax Digital HMRC submission</a:t>
+            </a:r>
+          </a:p>
+        </p:txBody>
+      </p:sp>
+      <p:sp>
+        <p:nvSpPr>
+          <p:cNvPr id="6" name="Rectangle 5"/>
+          <p:cNvSpPr/>
+          <p:nvPr/>
+        </p:nvSpPr>
+        <p:spPr>
+          <a:xfrm>
+            <a:off x="0" y="6601968"/>
+            <a:ext cx="12188952" cy="256032"/>
+          </a:xfrm>
+          <a:prstGeom prst="rect">
+            <a:avLst/>
+          </a:prstGeom>
+          <a:solidFill>
+            <a:srgbClr val="1C1917"/>
+          </a:solidFill>
+          <a:ln>
+            <a:noFill/>
+          </a:ln>
+        </p:spPr>
+        <p:style>
+          <a:lnRef idx="1">
+            <a:schemeClr val="accent1"/>
+          </a:lnRef>
+          <a:fillRef idx="3">
+            <a:schemeClr val="accent1"/>
+          </a:fillRef>
+          <a:effectRef idx="2">
+            <a:schemeClr val="accent1"/>
+          </a:effectRef>
+          <a:fontRef idx="minor">
+            <a:schemeClr val="lt1"/>
+          </a:fontRef>
+        </p:style>
+        <p:txBody>
+          <a:bodyPr rtlCol="0" anchor="ctr"/>
+          <a:lstStyle/>
+          <a:p>
+            <a:pPr algn="ctr"/>
+          </a:p>
+        </p:txBody>
+      </p:sp>
+      <p:sp>
+        <p:nvSpPr>
+          <p:cNvPr id="7" name="TextBox 6"/>
+          <p:cNvSpPr txBox="1"/>
+          <p:nvPr/>
+        </p:nvSpPr>
+        <p:spPr>
+          <a:xfrm>
+            <a:off x="457200" y="6620256"/>
+            <a:ext cx="2743200" cy="201168"/>
+          </a:xfrm>
+          <a:prstGeom prst="rect">
+            <a:avLst/>
+          </a:prstGeom>
+          <a:noFill/>
+        </p:spPr>
+        <p:txBody>
+          <a:bodyPr wrap="square">
+            <a:spAutoFit/>
+          </a:bodyPr>
+          <a:lstStyle/>
+          <a:p>
+            <a:pPr algn="l"/>
+            <a:r>
+              <a:rPr sz="800" b="1" i="0">
+                <a:solidFill>
+                  <a:srgbClr val="FECACA"/>
+                </a:solidFill>
+                <a:latin typeface="Calibri"/>
+              </a:rPr>
+              <a:t>INTERNAL · CONFIDENTIAL</a:t>
+            </a:r>
+          </a:p>
+        </p:txBody>
+      </p:sp>
+      <p:sp>
+        <p:nvSpPr>
+          <p:cNvPr id="8" name="TextBox 7"/>
+          <p:cNvSpPr txBox="1"/>
+          <p:nvPr/>
+        </p:nvSpPr>
+        <p:spPr>
+          <a:xfrm>
+            <a:off x="3200400" y="6620256"/>
+            <a:ext cx="7863840" cy="201168"/>
+          </a:xfrm>
+          <a:prstGeom prst="rect">
+            <a:avLst/>
+          </a:prstGeom>
+          <a:noFill/>
+        </p:spPr>
+        <p:txBody>
+          <a:bodyPr wrap="square">
+            <a:spAutoFit/>
+          </a:bodyPr>
+          <a:lstStyle/>
+          <a:p>
+            <a:pPr algn="r"/>
+            <a:r>
+              <a:rPr sz="800" b="0" i="1">
+                <a:solidFill>
+                  <a:srgbClr val="D6D3D1"/>
+                </a:solidFill>
+                <a:latin typeface="Calibri"/>
+              </a:rPr>
+              <a:t>Alan Davidson · Business Banking Advisor · Self-initiated · Own time · June 2026</a:t>
+            </a:r>
+          </a:p>
+        </p:txBody>
+      </p:sp>
+      <p:sp>
+        <p:nvSpPr>
+          <p:cNvPr id="9" name="TextBox 8"/>
+          <p:cNvSpPr txBox="1"/>
+          <p:nvPr/>
+        </p:nvSpPr>
+        <p:spPr>
+          <a:xfrm>
+            <a:off x="11750040" y="6620256"/>
+            <a:ext cx="365760" cy="201168"/>
+          </a:xfrm>
+          <a:prstGeom prst="rect">
+            <a:avLst/>
+          </a:prstGeom>
+          <a:noFill/>
+        </p:spPr>
+        <p:txBody>
+          <a:bodyPr wrap="square">
+            <a:spAutoFit/>
+          </a:bodyPr>
+          <a:lstStyle/>
+          <a:p>
+            <a:pPr algn="r"/>
+            <a:r>
+              <a:rPr sz="800" b="0" i="0">
+                <a:solidFill>
+                  <a:srgbClr val="D6D3D1"/>
+                </a:solidFill>
+                <a:latin typeface="Calibri"/>
+              </a:rPr>
+              <a:t>9</a:t>
             </a:r>
           </a:p>
         </p:txBody>

</xml_diff>

<commit_message>
Brand: standardise all reds on #DA291C across app gradients and decks
- App: retired the older bright #ec0000 from the top-bar and card
  gradients; everything now the confirmed brand red #DA291C.
- Decks: recoloured all 5 in place (XML colour-value swap, 626 refs
  C8102E/EC0000 -> DA291C). Pure recolour — 0 overflow, layout untouched
  (verified). Deck builders' source red updated to match for future
  regens.
- Kept the decks' drawn flame + Calibri deliberately: swapping deck font
  to Santander Text risks unverifiable layout reflow; logo+font on decks
  left for a dedicated rebuild.

Whole prototype + reports + decks now on the official red; app + reports
also on the official logo and Santander Text (named, licence-safe).

Co-Authored-By: Claude Opus 4.8 <noreply@anthropic.com>
Claude-Session: https://claude.ai/code/session_012EFETGbhdxdnPCjpmQ9UDz
</commit_message>
<xml_diff>
--- a/Santander_Architecture.pptx
+++ b/Santander_Architecture.pptx
@@ -3157,7 +3157,7 @@
             <a:avLst/>
           </a:prstGeom>
           <a:solidFill>
-            <a:srgbClr val="C8102E"/>
+            <a:srgbClr val="DA291C"/>
           </a:solidFill>
           <a:ln>
             <a:noFill/>
@@ -3243,7 +3243,7 @@
             <a:avLst/>
           </a:prstGeom>
           <a:solidFill>
-            <a:srgbClr val="C8102E"/>
+            <a:srgbClr val="DA291C"/>
           </a:solidFill>
           <a:ln>
             <a:noFill/>
@@ -3356,7 +3356,7 @@
             <a:avLst/>
           </a:prstGeom>
           <a:solidFill>
-            <a:srgbClr val="C8102E"/>
+            <a:srgbClr val="DA291C"/>
           </a:solidFill>
           <a:ln>
             <a:noFill/>
@@ -3442,7 +3442,7 @@
             <a:avLst/>
           </a:prstGeom>
           <a:solidFill>
-            <a:srgbClr val="C8102E"/>
+            <a:srgbClr val="DA291C"/>
           </a:solidFill>
           <a:ln>
             <a:noFill/>
@@ -3598,7 +3598,7 @@
             <a:avLst/>
           </a:prstGeom>
           <a:solidFill>
-            <a:srgbClr val="C8102E"/>
+            <a:srgbClr val="DA291C"/>
           </a:solidFill>
           <a:ln>
             <a:noFill/>
@@ -3754,7 +3754,7 @@
             <a:avLst/>
           </a:prstGeom>
           <a:solidFill>
-            <a:srgbClr val="C8102E"/>
+            <a:srgbClr val="DA291C"/>
           </a:solidFill>
           <a:ln>
             <a:noFill/>
@@ -3910,7 +3910,7 @@
             <a:avLst/>
           </a:prstGeom>
           <a:solidFill>
-            <a:srgbClr val="C8102E"/>
+            <a:srgbClr val="DA291C"/>
           </a:solidFill>
           <a:ln>
             <a:noFill/>
@@ -4093,7 +4093,7 @@
             <a:avLst/>
           </a:prstGeom>
           <a:solidFill>
-            <a:srgbClr val="C8102E"/>
+            <a:srgbClr val="DA291C"/>
           </a:solidFill>
           <a:ln>
             <a:noFill/>
@@ -4232,7 +4232,7 @@
             <a:avLst/>
           </a:prstGeom>
           <a:solidFill>
-            <a:srgbClr val="C8102E"/>
+            <a:srgbClr val="DA291C"/>
           </a:solidFill>
           <a:ln>
             <a:noFill/>
@@ -4286,7 +4286,7 @@
             <a:r>
               <a:rPr sz="950" b="1" i="0">
                 <a:solidFill>
-                  <a:srgbClr val="C8102E"/>
+                  <a:srgbClr val="DA291C"/>
                 </a:solidFill>
                 <a:latin typeface="Calibri"/>
               </a:rPr>
@@ -4423,7 +4423,7 @@
             <a:avLst/>
           </a:prstGeom>
           <a:solidFill>
-            <a:srgbClr val="C8102E"/>
+            <a:srgbClr val="DA291C"/>
           </a:solidFill>
           <a:ln w="9525">
             <a:solidFill>
@@ -4939,7 +4939,7 @@
             <a:r>
               <a:rPr sz="1100" b="1" i="0">
                 <a:solidFill>
-                  <a:srgbClr val="C8102E"/>
+                  <a:srgbClr val="DA291C"/>
                 </a:solidFill>
                 <a:latin typeface="Calibri"/>
               </a:rPr>
@@ -5043,7 +5043,7 @@
             <a:avLst/>
           </a:prstGeom>
           <a:solidFill>
-            <a:srgbClr val="C8102E"/>
+            <a:srgbClr val="DA291C"/>
           </a:solidFill>
           <a:ln>
             <a:noFill/>
@@ -5205,7 +5205,7 @@
             <a:avLst/>
           </a:prstGeom>
           <a:solidFill>
-            <a:srgbClr val="C8102E"/>
+            <a:srgbClr val="DA291C"/>
           </a:solidFill>
           <a:ln>
             <a:noFill/>
@@ -5367,7 +5367,7 @@
             <a:avLst/>
           </a:prstGeom>
           <a:solidFill>
-            <a:srgbClr val="C8102E"/>
+            <a:srgbClr val="DA291C"/>
           </a:solidFill>
           <a:ln>
             <a:noFill/>
@@ -5529,7 +5529,7 @@
             <a:avLst/>
           </a:prstGeom>
           <a:solidFill>
-            <a:srgbClr val="C8102E"/>
+            <a:srgbClr val="DA291C"/>
           </a:solidFill>
           <a:ln>
             <a:noFill/>
@@ -5691,7 +5691,7 @@
             <a:avLst/>
           </a:prstGeom>
           <a:solidFill>
-            <a:srgbClr val="C8102E"/>
+            <a:srgbClr val="DA291C"/>
           </a:solidFill>
           <a:ln>
             <a:noFill/>
@@ -5853,7 +5853,7 @@
             <a:avLst/>
           </a:prstGeom>
           <a:solidFill>
-            <a:srgbClr val="C8102E"/>
+            <a:srgbClr val="DA291C"/>
           </a:solidFill>
           <a:ln>
             <a:noFill/>
@@ -6179,7 +6179,7 @@
             <a:avLst/>
           </a:prstGeom>
           <a:solidFill>
-            <a:srgbClr val="C8102E"/>
+            <a:srgbClr val="DA291C"/>
           </a:solidFill>
           <a:ln>
             <a:noFill/>
@@ -6233,7 +6233,7 @@
             <a:r>
               <a:rPr sz="950" b="1" i="0">
                 <a:solidFill>
-                  <a:srgbClr val="C8102E"/>
+                  <a:srgbClr val="DA291C"/>
                 </a:solidFill>
                 <a:latin typeface="Calibri"/>
               </a:rPr>
@@ -6381,7 +6381,7 @@
             <a:r>
               <a:rPr sz="1000" b="1" i="0">
                 <a:solidFill>
-                  <a:srgbClr val="C8102E"/>
+                  <a:srgbClr val="DA291C"/>
                 </a:solidFill>
                 <a:latin typeface="Calibri"/>
               </a:rPr>
@@ -6450,7 +6450,7 @@
             <a:avLst/>
           </a:prstGeom>
           <a:solidFill>
-            <a:srgbClr val="C8102E"/>
+            <a:srgbClr val="DA291C"/>
           </a:solidFill>
           <a:ln>
             <a:noFill/>
@@ -6612,7 +6612,7 @@
             <a:avLst/>
           </a:prstGeom>
           <a:solidFill>
-            <a:srgbClr val="C8102E"/>
+            <a:srgbClr val="DA291C"/>
           </a:solidFill>
           <a:ln>
             <a:noFill/>
@@ -6774,7 +6774,7 @@
             <a:avLst/>
           </a:prstGeom>
           <a:solidFill>
-            <a:srgbClr val="C8102E"/>
+            <a:srgbClr val="DA291C"/>
           </a:solidFill>
           <a:ln>
             <a:noFill/>
@@ -6902,7 +6902,7 @@
             <a:r>
               <a:rPr sz="1000" b="1" i="0">
                 <a:solidFill>
-                  <a:srgbClr val="C8102E"/>
+                  <a:srgbClr val="DA291C"/>
                 </a:solidFill>
                 <a:latin typeface="Calibri"/>
               </a:rPr>
@@ -7699,7 +7699,7 @@
             <a:avLst/>
           </a:prstGeom>
           <a:solidFill>
-            <a:srgbClr val="C8102E"/>
+            <a:srgbClr val="DA291C"/>
           </a:solidFill>
           <a:ln>
             <a:noFill/>
@@ -7753,7 +7753,7 @@
             <a:r>
               <a:rPr sz="950" b="1" i="0">
                 <a:solidFill>
-                  <a:srgbClr val="C8102E"/>
+                  <a:srgbClr val="DA291C"/>
                 </a:solidFill>
                 <a:latin typeface="Calibri"/>
               </a:rPr>
@@ -7935,7 +7935,7 @@
             <a:avLst/>
           </a:prstGeom>
           <a:solidFill>
-            <a:srgbClr val="C8102E"/>
+            <a:srgbClr val="DA291C"/>
           </a:solidFill>
           <a:ln>
             <a:noFill/>
@@ -8097,7 +8097,7 @@
             <a:avLst/>
           </a:prstGeom>
           <a:solidFill>
-            <a:srgbClr val="C8102E"/>
+            <a:srgbClr val="DA291C"/>
           </a:solidFill>
           <a:ln>
             <a:noFill/>
@@ -8259,7 +8259,7 @@
             <a:avLst/>
           </a:prstGeom>
           <a:solidFill>
-            <a:srgbClr val="C8102E"/>
+            <a:srgbClr val="DA291C"/>
           </a:solidFill>
           <a:ln>
             <a:noFill/>
@@ -8421,7 +8421,7 @@
             <a:avLst/>
           </a:prstGeom>
           <a:solidFill>
-            <a:srgbClr val="C8102E"/>
+            <a:srgbClr val="DA291C"/>
           </a:solidFill>
           <a:ln>
             <a:noFill/>
@@ -8583,7 +8583,7 @@
             <a:avLst/>
           </a:prstGeom>
           <a:solidFill>
-            <a:srgbClr val="C8102E"/>
+            <a:srgbClr val="DA291C"/>
           </a:solidFill>
           <a:ln>
             <a:noFill/>
@@ -8745,7 +8745,7 @@
             <a:avLst/>
           </a:prstGeom>
           <a:solidFill>
-            <a:srgbClr val="C8102E"/>
+            <a:srgbClr val="DA291C"/>
           </a:solidFill>
           <a:ln>
             <a:noFill/>
@@ -8907,7 +8907,7 @@
             <a:avLst/>
           </a:prstGeom>
           <a:solidFill>
-            <a:srgbClr val="C8102E"/>
+            <a:srgbClr val="DA291C"/>
           </a:solidFill>
           <a:ln>
             <a:noFill/>
@@ -9069,7 +9069,7 @@
             <a:avLst/>
           </a:prstGeom>
           <a:solidFill>
-            <a:srgbClr val="C8102E"/>
+            <a:srgbClr val="DA291C"/>
           </a:solidFill>
           <a:ln>
             <a:noFill/>
@@ -9395,7 +9395,7 @@
             <a:avLst/>
           </a:prstGeom>
           <a:solidFill>
-            <a:srgbClr val="C8102E"/>
+            <a:srgbClr val="DA291C"/>
           </a:solidFill>
           <a:ln>
             <a:noFill/>
@@ -9449,7 +9449,7 @@
             <a:r>
               <a:rPr sz="950" b="1" i="0">
                 <a:solidFill>
-                  <a:srgbClr val="C8102E"/>
+                  <a:srgbClr val="DA291C"/>
                 </a:solidFill>
                 <a:latin typeface="Calibri"/>
               </a:rPr>
@@ -9629,7 +9629,7 @@
             <a:avLst/>
           </a:prstGeom>
           <a:solidFill>
-            <a:srgbClr val="C8102E"/>
+            <a:srgbClr val="DA291C"/>
           </a:solidFill>
           <a:ln>
             <a:noFill/>
@@ -9785,7 +9785,7 @@
             <a:avLst/>
           </a:prstGeom>
           <a:solidFill>
-            <a:srgbClr val="C8102E"/>
+            <a:srgbClr val="DA291C"/>
           </a:solidFill>
           <a:ln>
             <a:noFill/>
@@ -9941,7 +9941,7 @@
             <a:avLst/>
           </a:prstGeom>
           <a:solidFill>
-            <a:srgbClr val="C8102E"/>
+            <a:srgbClr val="DA291C"/>
           </a:solidFill>
           <a:ln>
             <a:noFill/>
@@ -10099,7 +10099,7 @@
             <a:avLst/>
           </a:prstGeom>
           <a:solidFill>
-            <a:srgbClr val="C8102E"/>
+            <a:srgbClr val="DA291C"/>
           </a:solidFill>
           <a:ln>
             <a:noFill/>
@@ -10261,7 +10261,7 @@
             <a:avLst/>
           </a:prstGeom>
           <a:solidFill>
-            <a:srgbClr val="C8102E"/>
+            <a:srgbClr val="DA291C"/>
           </a:solidFill>
           <a:ln>
             <a:noFill/>
@@ -10423,7 +10423,7 @@
             <a:avLst/>
           </a:prstGeom>
           <a:solidFill>
-            <a:srgbClr val="C8102E"/>
+            <a:srgbClr val="DA291C"/>
           </a:solidFill>
           <a:ln>
             <a:noFill/>
@@ -10585,7 +10585,7 @@
             <a:avLst/>
           </a:prstGeom>
           <a:solidFill>
-            <a:srgbClr val="C8102E"/>
+            <a:srgbClr val="DA291C"/>
           </a:solidFill>
           <a:ln>
             <a:noFill/>
@@ -10747,7 +10747,7 @@
             <a:avLst/>
           </a:prstGeom>
           <a:solidFill>
-            <a:srgbClr val="C8102E"/>
+            <a:srgbClr val="DA291C"/>
           </a:solidFill>
           <a:ln>
             <a:noFill/>
@@ -10909,7 +10909,7 @@
             <a:avLst/>
           </a:prstGeom>
           <a:solidFill>
-            <a:srgbClr val="C8102E"/>
+            <a:srgbClr val="DA291C"/>
           </a:solidFill>
           <a:ln>
             <a:noFill/>
@@ -11235,7 +11235,7 @@
             <a:avLst/>
           </a:prstGeom>
           <a:solidFill>
-            <a:srgbClr val="C8102E"/>
+            <a:srgbClr val="DA291C"/>
           </a:solidFill>
           <a:ln>
             <a:noFill/>
@@ -11289,7 +11289,7 @@
             <a:r>
               <a:rPr sz="950" b="1" i="0">
                 <a:solidFill>
-                  <a:srgbClr val="C8102E"/>
+                  <a:srgbClr val="DA291C"/>
                 </a:solidFill>
                 <a:latin typeface="Calibri"/>
               </a:rPr>
@@ -11383,7 +11383,7 @@
             <a:avLst/>
           </a:prstGeom>
           <a:solidFill>
-            <a:srgbClr val="C8102E"/>
+            <a:srgbClr val="DA291C"/>
           </a:solidFill>
           <a:ln>
             <a:noFill/>
@@ -11469,7 +11469,7 @@
             <a:avLst/>
           </a:prstGeom>
           <a:solidFill>
-            <a:srgbClr val="C8102E"/>
+            <a:srgbClr val="DA291C"/>
           </a:solidFill>
           <a:ln>
             <a:noFill/>
@@ -11660,7 +11660,7 @@
             <a:avLst/>
           </a:prstGeom>
           <a:solidFill>
-            <a:srgbClr val="C8102E"/>
+            <a:srgbClr val="DA291C"/>
           </a:solidFill>
           <a:ln>
             <a:noFill/>
@@ -11851,7 +11851,7 @@
             <a:avLst/>
           </a:prstGeom>
           <a:solidFill>
-            <a:srgbClr val="C8102E"/>
+            <a:srgbClr val="DA291C"/>
           </a:solidFill>
           <a:ln>
             <a:noFill/>
@@ -12042,7 +12042,7 @@
             <a:avLst/>
           </a:prstGeom>
           <a:solidFill>
-            <a:srgbClr val="C8102E"/>
+            <a:srgbClr val="DA291C"/>
           </a:solidFill>
           <a:ln>
             <a:noFill/>
@@ -12233,7 +12233,7 @@
             <a:avLst/>
           </a:prstGeom>
           <a:solidFill>
-            <a:srgbClr val="C8102E"/>
+            <a:srgbClr val="DA291C"/>
           </a:solidFill>
           <a:ln>
             <a:noFill/>
@@ -12424,7 +12424,7 @@
             <a:avLst/>
           </a:prstGeom>
           <a:solidFill>
-            <a:srgbClr val="C8102E"/>
+            <a:srgbClr val="DA291C"/>
           </a:solidFill>
           <a:ln>
             <a:noFill/>
@@ -12615,7 +12615,7 @@
             <a:avLst/>
           </a:prstGeom>
           <a:solidFill>
-            <a:srgbClr val="C8102E"/>
+            <a:srgbClr val="DA291C"/>
           </a:solidFill>
           <a:ln>
             <a:noFill/>
@@ -12806,7 +12806,7 @@
             <a:avLst/>
           </a:prstGeom>
           <a:solidFill>
-            <a:srgbClr val="C8102E"/>
+            <a:srgbClr val="DA291C"/>
           </a:solidFill>
           <a:ln>
             <a:noFill/>
@@ -13163,7 +13163,7 @@
             <a:avLst/>
           </a:prstGeom>
           <a:solidFill>
-            <a:srgbClr val="C8102E"/>
+            <a:srgbClr val="DA291C"/>
           </a:solidFill>
           <a:ln>
             <a:noFill/>
@@ -13217,7 +13217,7 @@
             <a:r>
               <a:rPr sz="950" b="1" i="0">
                 <a:solidFill>
-                  <a:srgbClr val="C8102E"/>
+                  <a:srgbClr val="DA291C"/>
                 </a:solidFill>
                 <a:latin typeface="Calibri"/>
               </a:rPr>
@@ -13354,7 +13354,7 @@
             <a:avLst/>
           </a:prstGeom>
           <a:solidFill>
-            <a:srgbClr val="C8102E"/>
+            <a:srgbClr val="DA291C"/>
           </a:solidFill>
           <a:ln>
             <a:noFill/>
@@ -13512,7 +13512,7 @@
             <a:avLst/>
           </a:prstGeom>
           <a:solidFill>
-            <a:srgbClr val="C8102E"/>
+            <a:srgbClr val="DA291C"/>
           </a:solidFill>
           <a:ln>
             <a:noFill/>
@@ -13674,7 +13674,7 @@
             <a:avLst/>
           </a:prstGeom>
           <a:solidFill>
-            <a:srgbClr val="C8102E"/>
+            <a:srgbClr val="DA291C"/>
           </a:solidFill>
           <a:ln>
             <a:noFill/>
@@ -13836,7 +13836,7 @@
             <a:avLst/>
           </a:prstGeom>
           <a:solidFill>
-            <a:srgbClr val="C8102E"/>
+            <a:srgbClr val="DA291C"/>
           </a:solidFill>
           <a:ln>
             <a:noFill/>
@@ -13998,7 +13998,7 @@
             <a:avLst/>
           </a:prstGeom>
           <a:solidFill>
-            <a:srgbClr val="C8102E"/>
+            <a:srgbClr val="DA291C"/>
           </a:solidFill>
           <a:ln>
             <a:noFill/>
@@ -14160,7 +14160,7 @@
             <a:avLst/>
           </a:prstGeom>
           <a:solidFill>
-            <a:srgbClr val="C8102E"/>
+            <a:srgbClr val="DA291C"/>
           </a:solidFill>
           <a:ln>
             <a:noFill/>
@@ -14322,7 +14322,7 @@
             <a:avLst/>
           </a:prstGeom>
           <a:solidFill>
-            <a:srgbClr val="C8102E"/>
+            <a:srgbClr val="DA291C"/>
           </a:solidFill>
           <a:ln>
             <a:noFill/>
@@ -14648,7 +14648,7 @@
             <a:avLst/>
           </a:prstGeom>
           <a:solidFill>
-            <a:srgbClr val="C8102E"/>
+            <a:srgbClr val="DA291C"/>
           </a:solidFill>
           <a:ln>
             <a:noFill/>
@@ -14702,7 +14702,7 @@
             <a:r>
               <a:rPr sz="950" b="1" i="0">
                 <a:solidFill>
-                  <a:srgbClr val="C8102E"/>
+                  <a:srgbClr val="DA291C"/>
                 </a:solidFill>
                 <a:latin typeface="Calibri"/>
               </a:rPr>
@@ -14884,7 +14884,7 @@
             <a:avLst/>
           </a:prstGeom>
           <a:solidFill>
-            <a:srgbClr val="C8102E"/>
+            <a:srgbClr val="DA291C"/>
           </a:solidFill>
           <a:ln>
             <a:noFill/>
@@ -14993,7 +14993,7 @@
             <a:r>
               <a:rPr sz="1600" b="1" i="0">
                 <a:solidFill>
-                  <a:srgbClr val="C8102E"/>
+                  <a:srgbClr val="DA291C"/>
                 </a:solidFill>
                 <a:latin typeface="Calibri"/>
               </a:rPr>
@@ -15187,7 +15187,7 @@
             <a:r>
               <a:rPr sz="1600" b="1" i="0">
                 <a:solidFill>
-                  <a:srgbClr val="C8102E"/>
+                  <a:srgbClr val="DA291C"/>
                 </a:solidFill>
                 <a:latin typeface="Calibri"/>
               </a:rPr>
@@ -15383,7 +15383,7 @@
             <a:avLst/>
           </a:prstGeom>
           <a:solidFill>
-            <a:srgbClr val="C8102E"/>
+            <a:srgbClr val="DA291C"/>
           </a:solidFill>
           <a:ln>
             <a:noFill/>
@@ -15999,7 +15999,7 @@
             <a:avLst/>
           </a:prstGeom>
           <a:solidFill>
-            <a:srgbClr val="C8102E"/>
+            <a:srgbClr val="DA291C"/>
           </a:solidFill>
           <a:ln>
             <a:noFill/>
@@ -16053,7 +16053,7 @@
             <a:r>
               <a:rPr sz="950" b="1" i="0">
                 <a:solidFill>
-                  <a:srgbClr val="C8102E"/>
+                  <a:srgbClr val="DA291C"/>
                 </a:solidFill>
                 <a:latin typeface="Calibri"/>
               </a:rPr>
@@ -16233,7 +16233,7 @@
             <a:avLst/>
           </a:prstGeom>
           <a:solidFill>
-            <a:srgbClr val="C8102E"/>
+            <a:srgbClr val="DA291C"/>
           </a:solidFill>
           <a:ln>
             <a:noFill/>
@@ -16354,7 +16354,7 @@
             <a:avLst/>
           </a:prstGeom>
           <a:solidFill>
-            <a:srgbClr val="C8102E"/>
+            <a:srgbClr val="DA291C"/>
           </a:solidFill>
           <a:ln>
             <a:noFill/>
@@ -16475,7 +16475,7 @@
             <a:avLst/>
           </a:prstGeom>
           <a:solidFill>
-            <a:srgbClr val="C8102E"/>
+            <a:srgbClr val="DA291C"/>
           </a:solidFill>
           <a:ln>
             <a:noFill/>
@@ -16596,7 +16596,7 @@
             <a:avLst/>
           </a:prstGeom>
           <a:solidFill>
-            <a:srgbClr val="C8102E"/>
+            <a:srgbClr val="DA291C"/>
           </a:solidFill>
           <a:ln>
             <a:noFill/>
@@ -16717,7 +16717,7 @@
             <a:avLst/>
           </a:prstGeom>
           <a:solidFill>
-            <a:srgbClr val="C8102E"/>
+            <a:srgbClr val="DA291C"/>
           </a:solidFill>
           <a:ln>
             <a:noFill/>
@@ -16838,7 +16838,7 @@
             <a:avLst/>
           </a:prstGeom>
           <a:solidFill>
-            <a:srgbClr val="C8102E"/>
+            <a:srgbClr val="DA291C"/>
           </a:solidFill>
           <a:ln>
             <a:noFill/>
@@ -16959,7 +16959,7 @@
             <a:avLst/>
           </a:prstGeom>
           <a:solidFill>
-            <a:srgbClr val="C8102E"/>
+            <a:srgbClr val="DA291C"/>
           </a:solidFill>
           <a:ln>
             <a:noFill/>
@@ -17117,7 +17117,7 @@
             <a:avLst/>
           </a:prstGeom>
           <a:solidFill>
-            <a:srgbClr val="C8102E"/>
+            <a:srgbClr val="DA291C"/>
           </a:solidFill>
           <a:ln>
             <a:noFill/>
@@ -17279,7 +17279,7 @@
             <a:avLst/>
           </a:prstGeom>
           <a:solidFill>
-            <a:srgbClr val="C8102E"/>
+            <a:srgbClr val="DA291C"/>
           </a:solidFill>
           <a:ln>
             <a:noFill/>
@@ -17441,7 +17441,7 @@
             <a:avLst/>
           </a:prstGeom>
           <a:solidFill>
-            <a:srgbClr val="C8102E"/>
+            <a:srgbClr val="DA291C"/>
           </a:solidFill>
           <a:ln>
             <a:noFill/>
@@ -17603,7 +17603,7 @@
             <a:avLst/>
           </a:prstGeom>
           <a:solidFill>
-            <a:srgbClr val="C8102E"/>
+            <a:srgbClr val="DA291C"/>
           </a:solidFill>
           <a:ln>
             <a:noFill/>
@@ -17765,7 +17765,7 @@
             <a:avLst/>
           </a:prstGeom>
           <a:solidFill>
-            <a:srgbClr val="C8102E"/>
+            <a:srgbClr val="DA291C"/>
           </a:solidFill>
           <a:ln>
             <a:noFill/>
@@ -17927,7 +17927,7 @@
             <a:avLst/>
           </a:prstGeom>
           <a:solidFill>
-            <a:srgbClr val="C8102E"/>
+            <a:srgbClr val="DA291C"/>
           </a:solidFill>
           <a:ln>
             <a:noFill/>
@@ -18253,7 +18253,7 @@
             <a:avLst/>
           </a:prstGeom>
           <a:solidFill>
-            <a:srgbClr val="C8102E"/>
+            <a:srgbClr val="DA291C"/>
           </a:solidFill>
           <a:ln>
             <a:noFill/>
@@ -18307,7 +18307,7 @@
             <a:r>
               <a:rPr sz="950" b="1" i="0">
                 <a:solidFill>
-                  <a:srgbClr val="C8102E"/>
+                  <a:srgbClr val="DA291C"/>
                 </a:solidFill>
                 <a:latin typeface="Calibri"/>
               </a:rPr>
@@ -18875,7 +18875,7 @@
             <a:avLst/>
           </a:prstGeom>
           <a:solidFill>
-            <a:srgbClr val="C8102E"/>
+            <a:srgbClr val="DA291C"/>
           </a:solidFill>
           <a:ln>
             <a:noFill/>
@@ -19138,7 +19138,7 @@
             <a:avLst/>
           </a:prstGeom>
           <a:solidFill>
-            <a:srgbClr val="C8102E"/>
+            <a:srgbClr val="DA291C"/>
           </a:solidFill>
           <a:ln>
             <a:noFill/>
@@ -19460,7 +19460,7 @@
             <a:avLst/>
           </a:prstGeom>
           <a:solidFill>
-            <a:srgbClr val="C8102E"/>
+            <a:srgbClr val="DA291C"/>
           </a:solidFill>
           <a:ln>
             <a:noFill/>
@@ -19514,7 +19514,7 @@
             <a:r>
               <a:rPr sz="950" b="1" i="0">
                 <a:solidFill>
-                  <a:srgbClr val="C8102E"/>
+                  <a:srgbClr val="DA291C"/>
                 </a:solidFill>
                 <a:latin typeface="Calibri"/>
               </a:rPr>
@@ -19696,7 +19696,7 @@
             <a:avLst/>
           </a:prstGeom>
           <a:solidFill>
-            <a:srgbClr val="C8102E"/>
+            <a:srgbClr val="DA291C"/>
           </a:solidFill>
           <a:ln>
             <a:noFill/>
@@ -20520,7 +20520,7 @@
             <a:avLst/>
           </a:prstGeom>
           <a:solidFill>
-            <a:srgbClr val="C8102E"/>
+            <a:srgbClr val="DA291C"/>
           </a:solidFill>
           <a:ln>
             <a:noFill/>
@@ -20574,7 +20574,7 @@
             <a:r>
               <a:rPr sz="950" b="1" i="0">
                 <a:solidFill>
-                  <a:srgbClr val="C8102E"/>
+                  <a:srgbClr val="DA291C"/>
                 </a:solidFill>
                 <a:latin typeface="Calibri"/>
               </a:rPr>
@@ -20756,7 +20756,7 @@
             <a:avLst/>
           </a:prstGeom>
           <a:solidFill>
-            <a:srgbClr val="C8102E"/>
+            <a:srgbClr val="DA291C"/>
           </a:solidFill>
           <a:ln>
             <a:noFill/>
@@ -20845,7 +20845,7 @@
             <a:r>
               <a:rPr sz="850" b="1" i="0">
                 <a:solidFill>
-                  <a:srgbClr val="C8102E"/>
+                  <a:srgbClr val="DA291C"/>
                 </a:solidFill>
                 <a:latin typeface="Calibri"/>
               </a:rPr>
@@ -20949,7 +20949,7 @@
             <a:avLst/>
           </a:prstGeom>
           <a:solidFill>
-            <a:srgbClr val="C8102E"/>
+            <a:srgbClr val="DA291C"/>
           </a:solidFill>
           <a:ln>
             <a:noFill/>
@@ -21038,7 +21038,7 @@
             <a:r>
               <a:rPr sz="850" b="1" i="0">
                 <a:solidFill>
-                  <a:srgbClr val="C8102E"/>
+                  <a:srgbClr val="DA291C"/>
                 </a:solidFill>
                 <a:latin typeface="Calibri"/>
               </a:rPr>
@@ -21142,7 +21142,7 @@
             <a:avLst/>
           </a:prstGeom>
           <a:solidFill>
-            <a:srgbClr val="C8102E"/>
+            <a:srgbClr val="DA291C"/>
           </a:solidFill>
           <a:ln>
             <a:noFill/>
@@ -21231,7 +21231,7 @@
             <a:r>
               <a:rPr sz="850" b="1" i="0">
                 <a:solidFill>
-                  <a:srgbClr val="C8102E"/>
+                  <a:srgbClr val="DA291C"/>
                 </a:solidFill>
                 <a:latin typeface="Calibri"/>
               </a:rPr>
@@ -21335,7 +21335,7 @@
             <a:avLst/>
           </a:prstGeom>
           <a:solidFill>
-            <a:srgbClr val="C8102E"/>
+            <a:srgbClr val="DA291C"/>
           </a:solidFill>
           <a:ln>
             <a:noFill/>
@@ -21424,7 +21424,7 @@
             <a:r>
               <a:rPr sz="850" b="1" i="0">
                 <a:solidFill>
-                  <a:srgbClr val="C8102E"/>
+                  <a:srgbClr val="DA291C"/>
                 </a:solidFill>
                 <a:latin typeface="Calibri"/>
               </a:rPr>
@@ -21528,7 +21528,7 @@
             <a:avLst/>
           </a:prstGeom>
           <a:solidFill>
-            <a:srgbClr val="C8102E"/>
+            <a:srgbClr val="DA291C"/>
           </a:solidFill>
           <a:ln>
             <a:noFill/>
@@ -21617,7 +21617,7 @@
             <a:r>
               <a:rPr sz="850" b="1" i="0">
                 <a:solidFill>
-                  <a:srgbClr val="C8102E"/>
+                  <a:srgbClr val="DA291C"/>
                 </a:solidFill>
                 <a:latin typeface="Calibri"/>
               </a:rPr>
@@ -21721,7 +21721,7 @@
             <a:avLst/>
           </a:prstGeom>
           <a:solidFill>
-            <a:srgbClr val="C8102E"/>
+            <a:srgbClr val="DA291C"/>
           </a:solidFill>
           <a:ln>
             <a:noFill/>
@@ -21810,7 +21810,7 @@
             <a:r>
               <a:rPr sz="850" b="1" i="0">
                 <a:solidFill>
-                  <a:srgbClr val="C8102E"/>
+                  <a:srgbClr val="DA291C"/>
                 </a:solidFill>
                 <a:latin typeface="Calibri"/>
               </a:rPr>
@@ -21914,7 +21914,7 @@
             <a:avLst/>
           </a:prstGeom>
           <a:solidFill>
-            <a:srgbClr val="C8102E"/>
+            <a:srgbClr val="DA291C"/>
           </a:solidFill>
           <a:ln>
             <a:noFill/>
@@ -22003,7 +22003,7 @@
             <a:r>
               <a:rPr sz="850" b="1" i="0">
                 <a:solidFill>
-                  <a:srgbClr val="C8102E"/>
+                  <a:srgbClr val="DA291C"/>
                 </a:solidFill>
                 <a:latin typeface="Calibri"/>
               </a:rPr>
@@ -22107,7 +22107,7 @@
             <a:avLst/>
           </a:prstGeom>
           <a:solidFill>
-            <a:srgbClr val="C8102E"/>
+            <a:srgbClr val="DA291C"/>
           </a:solidFill>
           <a:ln>
             <a:noFill/>
@@ -22196,7 +22196,7 @@
             <a:r>
               <a:rPr sz="850" b="1" i="0">
                 <a:solidFill>
-                  <a:srgbClr val="C8102E"/>
+                  <a:srgbClr val="DA291C"/>
                 </a:solidFill>
                 <a:latin typeface="Calibri"/>
               </a:rPr>
@@ -22300,7 +22300,7 @@
             <a:avLst/>
           </a:prstGeom>
           <a:solidFill>
-            <a:srgbClr val="C8102E"/>
+            <a:srgbClr val="DA291C"/>
           </a:solidFill>
           <a:ln>
             <a:noFill/>
@@ -22389,7 +22389,7 @@
             <a:r>
               <a:rPr sz="850" b="1" i="0">
                 <a:solidFill>
-                  <a:srgbClr val="C8102E"/>
+                  <a:srgbClr val="DA291C"/>
                 </a:solidFill>
                 <a:latin typeface="Calibri"/>
               </a:rPr>
@@ -22493,7 +22493,7 @@
             <a:avLst/>
           </a:prstGeom>
           <a:solidFill>
-            <a:srgbClr val="C8102E"/>
+            <a:srgbClr val="DA291C"/>
           </a:solidFill>
           <a:ln>
             <a:noFill/>
@@ -22582,7 +22582,7 @@
             <a:r>
               <a:rPr sz="850" b="1" i="0">
                 <a:solidFill>
-                  <a:srgbClr val="C8102E"/>
+                  <a:srgbClr val="DA291C"/>
                 </a:solidFill>
                 <a:latin typeface="Calibri"/>
               </a:rPr>
@@ -22686,7 +22686,7 @@
             <a:avLst/>
           </a:prstGeom>
           <a:solidFill>
-            <a:srgbClr val="C8102E"/>
+            <a:srgbClr val="DA291C"/>
           </a:solidFill>
           <a:ln>
             <a:noFill/>
@@ -22775,7 +22775,7 @@
             <a:r>
               <a:rPr sz="850" b="1" i="0">
                 <a:solidFill>
-                  <a:srgbClr val="C8102E"/>
+                  <a:srgbClr val="DA291C"/>
                 </a:solidFill>
                 <a:latin typeface="Calibri"/>
               </a:rPr>
@@ -22879,7 +22879,7 @@
             <a:avLst/>
           </a:prstGeom>
           <a:solidFill>
-            <a:srgbClr val="C8102E"/>
+            <a:srgbClr val="DA291C"/>
           </a:solidFill>
           <a:ln>
             <a:noFill/>
@@ -22968,7 +22968,7 @@
             <a:r>
               <a:rPr sz="850" b="1" i="0">
                 <a:solidFill>
-                  <a:srgbClr val="C8102E"/>
+                  <a:srgbClr val="DA291C"/>
                 </a:solidFill>
                 <a:latin typeface="Calibri"/>
               </a:rPr>

</xml_diff>

<commit_message>
Decks: put the official Santander logo on all 5 covers
Answer to "is the logo on the PowerPoints?" — now yes. Placed the
official white logo (dark covers) top-left on every deck cover, removed
the red-square placeholder marks (Architecture/Future/Project Record)
and the redundant top-left "Santander" text labels (June2026/Walkthrough)
that would have overlapped it. Verified each cover visually with the new
deck_to_html.py renderer; 0 overflow across all decks.

Deck body font stays Calibri (Santander Text swap risks unverifiable
reflow). Noted: deck stat counts are stale ("12"/"13" workflows vs 17) —
a content refresh, flagged for a follow-up.

Co-Authored-By: Claude Opus 4.8 <noreply@anthropic.com>
Claude-Session: https://claude.ai/code/session_012EFETGbhdxdnPCjpmQ9UDz
</commit_message>
<xml_diff>
--- a/Santander_Architecture.pptx
+++ b/Santander_Architecture.pptx
@@ -3230,14 +3230,84 @@
       </p:sp>
       <p:sp>
         <p:nvSpPr>
-          <p:cNvPr id="5" name="Rectangle 4"/>
+          <p:cNvPr id="6" name="TextBox 5"/>
+          <p:cNvSpPr txBox="1"/>
+          <p:nvPr/>
+        </p:nvSpPr>
+        <p:spPr>
+          <a:xfrm>
+            <a:off x="502920" y="1783080"/>
+            <a:ext cx="10058400" cy="822960"/>
+          </a:xfrm>
+          <a:prstGeom prst="rect">
+            <a:avLst/>
+          </a:prstGeom>
+          <a:noFill/>
+        </p:spPr>
+        <p:txBody>
+          <a:bodyPr wrap="square">
+            <a:noAutofit/>
+          </a:bodyPr>
+          <a:lstStyle/>
+          <a:p>
+            <a:pPr algn="l"/>
+            <a:r>
+              <a:rPr sz="5000" b="1" i="0">
+                <a:solidFill>
+                  <a:srgbClr val="FFFFFF"/>
+                </a:solidFill>
+                <a:latin typeface="Calibri"/>
+              </a:rPr>
+              <a:t>Architecture Report</a:t>
+            </a:r>
+          </a:p>
+        </p:txBody>
+      </p:sp>
+      <p:sp>
+        <p:nvSpPr>
+          <p:cNvPr id="7" name="TextBox 6"/>
+          <p:cNvSpPr txBox="1"/>
+          <p:nvPr/>
+        </p:nvSpPr>
+        <p:spPr>
+          <a:xfrm>
+            <a:off x="502920" y="2697480"/>
+            <a:ext cx="10058400" cy="502920"/>
+          </a:xfrm>
+          <a:prstGeom prst="rect">
+            <a:avLst/>
+          </a:prstGeom>
+          <a:noFill/>
+        </p:spPr>
+        <p:txBody>
+          <a:bodyPr wrap="square">
+            <a:noAutofit/>
+          </a:bodyPr>
+          <a:lstStyle/>
+          <a:p>
+            <a:pPr algn="l"/>
+            <a:r>
+              <a:rPr sz="2200" b="0" i="0">
+                <a:solidFill>
+                  <a:srgbClr val="FECACA"/>
+                </a:solidFill>
+                <a:latin typeface="Calibri"/>
+              </a:rPr>
+              <a:t>Santander Business Banking Prototype</a:t>
+            </a:r>
+          </a:p>
+        </p:txBody>
+      </p:sp>
+      <p:sp>
+        <p:nvSpPr>
+          <p:cNvPr id="8" name="Rectangle 7"/>
           <p:cNvSpPr/>
           <p:nvPr/>
         </p:nvSpPr>
         <p:spPr>
           <a:xfrm>
-            <a:off x="502920" y="1188720"/>
-            <a:ext cx="457200" cy="457200"/>
+            <a:off x="502920" y="3310128"/>
+            <a:ext cx="7772400" cy="36576"/>
           </a:xfrm>
           <a:prstGeom prst="rect">
             <a:avLst/>
@@ -3273,90 +3343,20 @@
       </p:sp>
       <p:sp>
         <p:nvSpPr>
-          <p:cNvPr id="6" name="TextBox 5"/>
-          <p:cNvSpPr txBox="1"/>
-          <p:nvPr/>
-        </p:nvSpPr>
-        <p:spPr>
-          <a:xfrm>
-            <a:off x="502920" y="1783080"/>
-            <a:ext cx="10058400" cy="822960"/>
-          </a:xfrm>
-          <a:prstGeom prst="rect">
-            <a:avLst/>
-          </a:prstGeom>
-          <a:noFill/>
-        </p:spPr>
-        <p:txBody>
-          <a:bodyPr wrap="square">
-            <a:noAutofit/>
-          </a:bodyPr>
-          <a:lstStyle/>
-          <a:p>
-            <a:pPr algn="l"/>
-            <a:r>
-              <a:rPr sz="5000" b="1" i="0">
-                <a:solidFill>
-                  <a:srgbClr val="FFFFFF"/>
-                </a:solidFill>
-                <a:latin typeface="Calibri"/>
-              </a:rPr>
-              <a:t>Architecture Report</a:t>
-            </a:r>
-          </a:p>
-        </p:txBody>
-      </p:sp>
-      <p:sp>
-        <p:nvSpPr>
-          <p:cNvPr id="7" name="TextBox 6"/>
-          <p:cNvSpPr txBox="1"/>
-          <p:nvPr/>
-        </p:nvSpPr>
-        <p:spPr>
-          <a:xfrm>
-            <a:off x="502920" y="2697480"/>
-            <a:ext cx="10058400" cy="502920"/>
-          </a:xfrm>
-          <a:prstGeom prst="rect">
-            <a:avLst/>
-          </a:prstGeom>
-          <a:noFill/>
-        </p:spPr>
-        <p:txBody>
-          <a:bodyPr wrap="square">
-            <a:noAutofit/>
-          </a:bodyPr>
-          <a:lstStyle/>
-          <a:p>
-            <a:pPr algn="l"/>
-            <a:r>
-              <a:rPr sz="2200" b="0" i="0">
-                <a:solidFill>
-                  <a:srgbClr val="FECACA"/>
-                </a:solidFill>
-                <a:latin typeface="Calibri"/>
-              </a:rPr>
-              <a:t>Santander Business Banking Prototype</a:t>
-            </a:r>
-          </a:p>
-        </p:txBody>
-      </p:sp>
-      <p:sp>
-        <p:nvSpPr>
-          <p:cNvPr id="8" name="Rectangle 7"/>
+          <p:cNvPr id="9" name="Rectangle 8"/>
           <p:cNvSpPr/>
           <p:nvPr/>
         </p:nvSpPr>
         <p:spPr>
           <a:xfrm>
-            <a:off x="502920" y="3310128"/>
-            <a:ext cx="7772400" cy="36576"/>
-          </a:xfrm>
-          <a:prstGeom prst="rect">
-            <a:avLst/>
-          </a:prstGeom>
-          <a:solidFill>
-            <a:srgbClr val="DA291C"/>
+            <a:off x="502920" y="3520440"/>
+            <a:ext cx="2286000" cy="822960"/>
+          </a:xfrm>
+          <a:prstGeom prst="rect">
+            <a:avLst/>
+          </a:prstGeom>
+          <a:solidFill>
+            <a:srgbClr val="44403C"/>
           </a:solidFill>
           <a:ln>
             <a:noFill/>
@@ -3386,20 +3386,20 @@
       </p:sp>
       <p:sp>
         <p:nvSpPr>
-          <p:cNvPr id="9" name="Rectangle 8"/>
+          <p:cNvPr id="10" name="Rectangle 9"/>
           <p:cNvSpPr/>
           <p:nvPr/>
         </p:nvSpPr>
         <p:spPr>
           <a:xfrm>
             <a:off x="502920" y="3520440"/>
-            <a:ext cx="2286000" cy="822960"/>
-          </a:xfrm>
-          <a:prstGeom prst="rect">
-            <a:avLst/>
-          </a:prstGeom>
-          <a:solidFill>
-            <a:srgbClr val="44403C"/>
+            <a:ext cx="2286000" cy="45720"/>
+          </a:xfrm>
+          <a:prstGeom prst="rect">
+            <a:avLst/>
+          </a:prstGeom>
+          <a:solidFill>
+            <a:srgbClr val="DA291C"/>
           </a:solidFill>
           <a:ln>
             <a:noFill/>
@@ -3429,20 +3429,90 @@
       </p:sp>
       <p:sp>
         <p:nvSpPr>
-          <p:cNvPr id="10" name="Rectangle 9"/>
+          <p:cNvPr id="11" name="TextBox 10"/>
+          <p:cNvSpPr txBox="1"/>
+          <p:nvPr/>
+        </p:nvSpPr>
+        <p:spPr>
+          <a:xfrm>
+            <a:off x="612648" y="3584448"/>
+            <a:ext cx="2103120" cy="457200"/>
+          </a:xfrm>
+          <a:prstGeom prst="rect">
+            <a:avLst/>
+          </a:prstGeom>
+          <a:noFill/>
+        </p:spPr>
+        <p:txBody>
+          <a:bodyPr wrap="square">
+            <a:noAutofit/>
+          </a:bodyPr>
+          <a:lstStyle/>
+          <a:p>
+            <a:pPr algn="l"/>
+            <a:r>
+              <a:rPr sz="2400" b="1" i="0">
+                <a:solidFill>
+                  <a:srgbClr val="FFFFFF"/>
+                </a:solidFill>
+                <a:latin typeface="Calibri"/>
+              </a:rPr>
+              <a:t>5,700</a:t>
+            </a:r>
+          </a:p>
+        </p:txBody>
+      </p:sp>
+      <p:sp>
+        <p:nvSpPr>
+          <p:cNvPr id="12" name="TextBox 11"/>
+          <p:cNvSpPr txBox="1"/>
+          <p:nvPr/>
+        </p:nvSpPr>
+        <p:spPr>
+          <a:xfrm>
+            <a:off x="630936" y="4041648"/>
+            <a:ext cx="2011680" cy="256032"/>
+          </a:xfrm>
+          <a:prstGeom prst="rect">
+            <a:avLst/>
+          </a:prstGeom>
+          <a:noFill/>
+        </p:spPr>
+        <p:txBody>
+          <a:bodyPr wrap="square">
+            <a:noAutofit/>
+          </a:bodyPr>
+          <a:lstStyle/>
+          <a:p>
+            <a:pPr algn="l"/>
+            <a:r>
+              <a:rPr sz="900" b="0" i="0">
+                <a:solidFill>
+                  <a:srgbClr val="D6D3D1"/>
+                </a:solidFill>
+                <a:latin typeface="Calibri"/>
+              </a:rPr>
+              <a:t>lines · 1 file</a:t>
+            </a:r>
+          </a:p>
+        </p:txBody>
+      </p:sp>
+      <p:sp>
+        <p:nvSpPr>
+          <p:cNvPr id="13" name="Rectangle 12"/>
           <p:cNvSpPr/>
           <p:nvPr/>
         </p:nvSpPr>
         <p:spPr>
           <a:xfrm>
-            <a:off x="502920" y="3520440"/>
-            <a:ext cx="2286000" cy="45720"/>
-          </a:xfrm>
-          <a:prstGeom prst="rect">
-            <a:avLst/>
-          </a:prstGeom>
-          <a:solidFill>
-            <a:srgbClr val="DA291C"/>
+            <a:off x="2971800" y="3520440"/>
+            <a:ext cx="2286000" cy="822960"/>
+          </a:xfrm>
+          <a:prstGeom prst="rect">
+            <a:avLst/>
+          </a:prstGeom>
+          <a:solidFill>
+            <a:srgbClr val="44403C"/>
           </a:solidFill>
           <a:ln>
             <a:noFill/>
@@ -3472,90 +3542,20 @@
       </p:sp>
       <p:sp>
         <p:nvSpPr>
-          <p:cNvPr id="11" name="TextBox 10"/>
-          <p:cNvSpPr txBox="1"/>
-          <p:nvPr/>
-        </p:nvSpPr>
-        <p:spPr>
-          <a:xfrm>
-            <a:off x="612648" y="3584448"/>
-            <a:ext cx="2103120" cy="457200"/>
-          </a:xfrm>
-          <a:prstGeom prst="rect">
-            <a:avLst/>
-          </a:prstGeom>
-          <a:noFill/>
-        </p:spPr>
-        <p:txBody>
-          <a:bodyPr wrap="square">
-            <a:noAutofit/>
-          </a:bodyPr>
-          <a:lstStyle/>
-          <a:p>
-            <a:pPr algn="l"/>
-            <a:r>
-              <a:rPr sz="2400" b="1" i="0">
-                <a:solidFill>
-                  <a:srgbClr val="FFFFFF"/>
-                </a:solidFill>
-                <a:latin typeface="Calibri"/>
-              </a:rPr>
-              <a:t>5,700</a:t>
-            </a:r>
-          </a:p>
-        </p:txBody>
-      </p:sp>
-      <p:sp>
-        <p:nvSpPr>
-          <p:cNvPr id="12" name="TextBox 11"/>
-          <p:cNvSpPr txBox="1"/>
-          <p:nvPr/>
-        </p:nvSpPr>
-        <p:spPr>
-          <a:xfrm>
-            <a:off x="630936" y="4041648"/>
-            <a:ext cx="2011680" cy="256032"/>
-          </a:xfrm>
-          <a:prstGeom prst="rect">
-            <a:avLst/>
-          </a:prstGeom>
-          <a:noFill/>
-        </p:spPr>
-        <p:txBody>
-          <a:bodyPr wrap="square">
-            <a:noAutofit/>
-          </a:bodyPr>
-          <a:lstStyle/>
-          <a:p>
-            <a:pPr algn="l"/>
-            <a:r>
-              <a:rPr sz="900" b="0" i="0">
-                <a:solidFill>
-                  <a:srgbClr val="D6D3D1"/>
-                </a:solidFill>
-                <a:latin typeface="Calibri"/>
-              </a:rPr>
-              <a:t>lines · 1 file</a:t>
-            </a:r>
-          </a:p>
-        </p:txBody>
-      </p:sp>
-      <p:sp>
-        <p:nvSpPr>
-          <p:cNvPr id="13" name="Rectangle 12"/>
+          <p:cNvPr id="14" name="Rectangle 13"/>
           <p:cNvSpPr/>
           <p:nvPr/>
         </p:nvSpPr>
         <p:spPr>
           <a:xfrm>
             <a:off x="2971800" y="3520440"/>
-            <a:ext cx="2286000" cy="822960"/>
-          </a:xfrm>
-          <a:prstGeom prst="rect">
-            <a:avLst/>
-          </a:prstGeom>
-          <a:solidFill>
-            <a:srgbClr val="44403C"/>
+            <a:ext cx="2286000" cy="45720"/>
+          </a:xfrm>
+          <a:prstGeom prst="rect">
+            <a:avLst/>
+          </a:prstGeom>
+          <a:solidFill>
+            <a:srgbClr val="DA291C"/>
           </a:solidFill>
           <a:ln>
             <a:noFill/>
@@ -3585,20 +3585,90 @@
       </p:sp>
       <p:sp>
         <p:nvSpPr>
-          <p:cNvPr id="14" name="Rectangle 13"/>
+          <p:cNvPr id="15" name="TextBox 14"/>
+          <p:cNvSpPr txBox="1"/>
+          <p:nvPr/>
+        </p:nvSpPr>
+        <p:spPr>
+          <a:xfrm>
+            <a:off x="3081528" y="3584448"/>
+            <a:ext cx="2103120" cy="457200"/>
+          </a:xfrm>
+          <a:prstGeom prst="rect">
+            <a:avLst/>
+          </a:prstGeom>
+          <a:noFill/>
+        </p:spPr>
+        <p:txBody>
+          <a:bodyPr wrap="square">
+            <a:noAutofit/>
+          </a:bodyPr>
+          <a:lstStyle/>
+          <a:p>
+            <a:pPr algn="l"/>
+            <a:r>
+              <a:rPr sz="2400" b="1" i="0">
+                <a:solidFill>
+                  <a:srgbClr val="FFFFFF"/>
+                </a:solidFill>
+                <a:latin typeface="Calibri"/>
+              </a:rPr>
+              <a:t>12</a:t>
+            </a:r>
+          </a:p>
+        </p:txBody>
+      </p:sp>
+      <p:sp>
+        <p:nvSpPr>
+          <p:cNvPr id="16" name="TextBox 15"/>
+          <p:cNvSpPr txBox="1"/>
+          <p:nvPr/>
+        </p:nvSpPr>
+        <p:spPr>
+          <a:xfrm>
+            <a:off x="3099816" y="4041648"/>
+            <a:ext cx="2011680" cy="256032"/>
+          </a:xfrm>
+          <a:prstGeom prst="rect">
+            <a:avLst/>
+          </a:prstGeom>
+          <a:noFill/>
+        </p:spPr>
+        <p:txBody>
+          <a:bodyPr wrap="square">
+            <a:noAutofit/>
+          </a:bodyPr>
+          <a:lstStyle/>
+          <a:p>
+            <a:pPr algn="l"/>
+            <a:r>
+              <a:rPr sz="900" b="0" i="0">
+                <a:solidFill>
+                  <a:srgbClr val="D6D3D1"/>
+                </a:solidFill>
+                <a:latin typeface="Calibri"/>
+              </a:rPr>
+              <a:t>workflows</a:t>
+            </a:r>
+          </a:p>
+        </p:txBody>
+      </p:sp>
+      <p:sp>
+        <p:nvSpPr>
+          <p:cNvPr id="17" name="Rectangle 16"/>
           <p:cNvSpPr/>
           <p:nvPr/>
         </p:nvSpPr>
         <p:spPr>
           <a:xfrm>
-            <a:off x="2971800" y="3520440"/>
-            <a:ext cx="2286000" cy="45720"/>
-          </a:xfrm>
-          <a:prstGeom prst="rect">
-            <a:avLst/>
-          </a:prstGeom>
-          <a:solidFill>
-            <a:srgbClr val="DA291C"/>
+            <a:off x="5440680" y="3520440"/>
+            <a:ext cx="2286000" cy="822960"/>
+          </a:xfrm>
+          <a:prstGeom prst="rect">
+            <a:avLst/>
+          </a:prstGeom>
+          <a:solidFill>
+            <a:srgbClr val="44403C"/>
           </a:solidFill>
           <a:ln>
             <a:noFill/>
@@ -3628,90 +3698,20 @@
       </p:sp>
       <p:sp>
         <p:nvSpPr>
-          <p:cNvPr id="15" name="TextBox 14"/>
-          <p:cNvSpPr txBox="1"/>
-          <p:nvPr/>
-        </p:nvSpPr>
-        <p:spPr>
-          <a:xfrm>
-            <a:off x="3081528" y="3584448"/>
-            <a:ext cx="2103120" cy="457200"/>
-          </a:xfrm>
-          <a:prstGeom prst="rect">
-            <a:avLst/>
-          </a:prstGeom>
-          <a:noFill/>
-        </p:spPr>
-        <p:txBody>
-          <a:bodyPr wrap="square">
-            <a:noAutofit/>
-          </a:bodyPr>
-          <a:lstStyle/>
-          <a:p>
-            <a:pPr algn="l"/>
-            <a:r>
-              <a:rPr sz="2400" b="1" i="0">
-                <a:solidFill>
-                  <a:srgbClr val="FFFFFF"/>
-                </a:solidFill>
-                <a:latin typeface="Calibri"/>
-              </a:rPr>
-              <a:t>12</a:t>
-            </a:r>
-          </a:p>
-        </p:txBody>
-      </p:sp>
-      <p:sp>
-        <p:nvSpPr>
-          <p:cNvPr id="16" name="TextBox 15"/>
-          <p:cNvSpPr txBox="1"/>
-          <p:nvPr/>
-        </p:nvSpPr>
-        <p:spPr>
-          <a:xfrm>
-            <a:off x="3099816" y="4041648"/>
-            <a:ext cx="2011680" cy="256032"/>
-          </a:xfrm>
-          <a:prstGeom prst="rect">
-            <a:avLst/>
-          </a:prstGeom>
-          <a:noFill/>
-        </p:spPr>
-        <p:txBody>
-          <a:bodyPr wrap="square">
-            <a:noAutofit/>
-          </a:bodyPr>
-          <a:lstStyle/>
-          <a:p>
-            <a:pPr algn="l"/>
-            <a:r>
-              <a:rPr sz="900" b="0" i="0">
-                <a:solidFill>
-                  <a:srgbClr val="D6D3D1"/>
-                </a:solidFill>
-                <a:latin typeface="Calibri"/>
-              </a:rPr>
-              <a:t>workflows</a:t>
-            </a:r>
-          </a:p>
-        </p:txBody>
-      </p:sp>
-      <p:sp>
-        <p:nvSpPr>
-          <p:cNvPr id="17" name="Rectangle 16"/>
+          <p:cNvPr id="18" name="Rectangle 17"/>
           <p:cNvSpPr/>
           <p:nvPr/>
         </p:nvSpPr>
         <p:spPr>
           <a:xfrm>
             <a:off x="5440680" y="3520440"/>
-            <a:ext cx="2286000" cy="822960"/>
-          </a:xfrm>
-          <a:prstGeom prst="rect">
-            <a:avLst/>
-          </a:prstGeom>
-          <a:solidFill>
-            <a:srgbClr val="44403C"/>
+            <a:ext cx="2286000" cy="45720"/>
+          </a:xfrm>
+          <a:prstGeom prst="rect">
+            <a:avLst/>
+          </a:prstGeom>
+          <a:solidFill>
+            <a:srgbClr val="DA291C"/>
           </a:solidFill>
           <a:ln>
             <a:noFill/>
@@ -3741,20 +3741,90 @@
       </p:sp>
       <p:sp>
         <p:nvSpPr>
-          <p:cNvPr id="18" name="Rectangle 17"/>
+          <p:cNvPr id="19" name="TextBox 18"/>
+          <p:cNvSpPr txBox="1"/>
+          <p:nvPr/>
+        </p:nvSpPr>
+        <p:spPr>
+          <a:xfrm>
+            <a:off x="5550408" y="3584448"/>
+            <a:ext cx="2103120" cy="457200"/>
+          </a:xfrm>
+          <a:prstGeom prst="rect">
+            <a:avLst/>
+          </a:prstGeom>
+          <a:noFill/>
+        </p:spPr>
+        <p:txBody>
+          <a:bodyPr wrap="square">
+            <a:noAutofit/>
+          </a:bodyPr>
+          <a:lstStyle/>
+          <a:p>
+            <a:pPr algn="l"/>
+            <a:r>
+              <a:rPr sz="2400" b="1" i="0">
+                <a:solidFill>
+                  <a:srgbClr val="FFFFFF"/>
+                </a:solidFill>
+                <a:latin typeface="Calibri"/>
+              </a:rPr>
+              <a:t>7</a:t>
+            </a:r>
+          </a:p>
+        </p:txBody>
+      </p:sp>
+      <p:sp>
+        <p:nvSpPr>
+          <p:cNvPr id="20" name="TextBox 19"/>
+          <p:cNvSpPr txBox="1"/>
+          <p:nvPr/>
+        </p:nvSpPr>
+        <p:spPr>
+          <a:xfrm>
+            <a:off x="5568696" y="4041648"/>
+            <a:ext cx="2011680" cy="256032"/>
+          </a:xfrm>
+          <a:prstGeom prst="rect">
+            <a:avLst/>
+          </a:prstGeom>
+          <a:noFill/>
+        </p:spPr>
+        <p:txBody>
+          <a:bodyPr wrap="square">
+            <a:noAutofit/>
+          </a:bodyPr>
+          <a:lstStyle/>
+          <a:p>
+            <a:pPr algn="l"/>
+            <a:r>
+              <a:rPr sz="900" b="0" i="0">
+                <a:solidFill>
+                  <a:srgbClr val="D6D3D1"/>
+                </a:solidFill>
+                <a:latin typeface="Calibri"/>
+              </a:rPr>
+              <a:t>entity types</a:t>
+            </a:r>
+          </a:p>
+        </p:txBody>
+      </p:sp>
+      <p:sp>
+        <p:nvSpPr>
+          <p:cNvPr id="21" name="Rectangle 20"/>
           <p:cNvSpPr/>
           <p:nvPr/>
         </p:nvSpPr>
         <p:spPr>
           <a:xfrm>
-            <a:off x="5440680" y="3520440"/>
-            <a:ext cx="2286000" cy="45720"/>
-          </a:xfrm>
-          <a:prstGeom prst="rect">
-            <a:avLst/>
-          </a:prstGeom>
-          <a:solidFill>
-            <a:srgbClr val="DA291C"/>
+            <a:off x="7909560" y="3520440"/>
+            <a:ext cx="2286000" cy="822960"/>
+          </a:xfrm>
+          <a:prstGeom prst="rect">
+            <a:avLst/>
+          </a:prstGeom>
+          <a:solidFill>
+            <a:srgbClr val="44403C"/>
           </a:solidFill>
           <a:ln>
             <a:noFill/>
@@ -3784,90 +3854,20 @@
       </p:sp>
       <p:sp>
         <p:nvSpPr>
-          <p:cNvPr id="19" name="TextBox 18"/>
-          <p:cNvSpPr txBox="1"/>
-          <p:nvPr/>
-        </p:nvSpPr>
-        <p:spPr>
-          <a:xfrm>
-            <a:off x="5550408" y="3584448"/>
-            <a:ext cx="2103120" cy="457200"/>
-          </a:xfrm>
-          <a:prstGeom prst="rect">
-            <a:avLst/>
-          </a:prstGeom>
-          <a:noFill/>
-        </p:spPr>
-        <p:txBody>
-          <a:bodyPr wrap="square">
-            <a:noAutofit/>
-          </a:bodyPr>
-          <a:lstStyle/>
-          <a:p>
-            <a:pPr algn="l"/>
-            <a:r>
-              <a:rPr sz="2400" b="1" i="0">
-                <a:solidFill>
-                  <a:srgbClr val="FFFFFF"/>
-                </a:solidFill>
-                <a:latin typeface="Calibri"/>
-              </a:rPr>
-              <a:t>7</a:t>
-            </a:r>
-          </a:p>
-        </p:txBody>
-      </p:sp>
-      <p:sp>
-        <p:nvSpPr>
-          <p:cNvPr id="20" name="TextBox 19"/>
-          <p:cNvSpPr txBox="1"/>
-          <p:nvPr/>
-        </p:nvSpPr>
-        <p:spPr>
-          <a:xfrm>
-            <a:off x="5568696" y="4041648"/>
-            <a:ext cx="2011680" cy="256032"/>
-          </a:xfrm>
-          <a:prstGeom prst="rect">
-            <a:avLst/>
-          </a:prstGeom>
-          <a:noFill/>
-        </p:spPr>
-        <p:txBody>
-          <a:bodyPr wrap="square">
-            <a:noAutofit/>
-          </a:bodyPr>
-          <a:lstStyle/>
-          <a:p>
-            <a:pPr algn="l"/>
-            <a:r>
-              <a:rPr sz="900" b="0" i="0">
-                <a:solidFill>
-                  <a:srgbClr val="D6D3D1"/>
-                </a:solidFill>
-                <a:latin typeface="Calibri"/>
-              </a:rPr>
-              <a:t>entity types</a:t>
-            </a:r>
-          </a:p>
-        </p:txBody>
-      </p:sp>
-      <p:sp>
-        <p:nvSpPr>
-          <p:cNvPr id="21" name="Rectangle 20"/>
+          <p:cNvPr id="22" name="Rectangle 21"/>
           <p:cNvSpPr/>
           <p:nvPr/>
         </p:nvSpPr>
         <p:spPr>
           <a:xfrm>
             <a:off x="7909560" y="3520440"/>
-            <a:ext cx="2286000" cy="822960"/>
-          </a:xfrm>
-          <a:prstGeom prst="rect">
-            <a:avLst/>
-          </a:prstGeom>
-          <a:solidFill>
-            <a:srgbClr val="44403C"/>
+            <a:ext cx="2286000" cy="45720"/>
+          </a:xfrm>
+          <a:prstGeom prst="rect">
+            <a:avLst/>
+          </a:prstGeom>
+          <a:solidFill>
+            <a:srgbClr val="DA291C"/>
           </a:solidFill>
           <a:ln>
             <a:noFill/>
@@ -3897,14 +3897,154 @@
       </p:sp>
       <p:sp>
         <p:nvSpPr>
-          <p:cNvPr id="22" name="Rectangle 21"/>
+          <p:cNvPr id="23" name="TextBox 22"/>
+          <p:cNvSpPr txBox="1"/>
+          <p:nvPr/>
+        </p:nvSpPr>
+        <p:spPr>
+          <a:xfrm>
+            <a:off x="8019288" y="3584448"/>
+            <a:ext cx="2103120" cy="457200"/>
+          </a:xfrm>
+          <a:prstGeom prst="rect">
+            <a:avLst/>
+          </a:prstGeom>
+          <a:noFill/>
+        </p:spPr>
+        <p:txBody>
+          <a:bodyPr wrap="square">
+            <a:noAutofit/>
+          </a:bodyPr>
+          <a:lstStyle/>
+          <a:p>
+            <a:pPr algn="l"/>
+            <a:r>
+              <a:rPr sz="2400" b="1" i="0">
+                <a:solidFill>
+                  <a:srgbClr val="FFFFFF"/>
+                </a:solidFill>
+                <a:latin typeface="Calibri"/>
+              </a:rPr>
+              <a:t>16:9</a:t>
+            </a:r>
+          </a:p>
+        </p:txBody>
+      </p:sp>
+      <p:sp>
+        <p:nvSpPr>
+          <p:cNvPr id="24" name="TextBox 23"/>
+          <p:cNvSpPr txBox="1"/>
+          <p:nvPr/>
+        </p:nvSpPr>
+        <p:spPr>
+          <a:xfrm>
+            <a:off x="8037576" y="4041648"/>
+            <a:ext cx="2011680" cy="256032"/>
+          </a:xfrm>
+          <a:prstGeom prst="rect">
+            <a:avLst/>
+          </a:prstGeom>
+          <a:noFill/>
+        </p:spPr>
+        <p:txBody>
+          <a:bodyPr wrap="square">
+            <a:noAutofit/>
+          </a:bodyPr>
+          <a:lstStyle/>
+          <a:p>
+            <a:pPr algn="l"/>
+            <a:r>
+              <a:rPr sz="900" b="0" i="0">
+                <a:solidFill>
+                  <a:srgbClr val="D6D3D1"/>
+                </a:solidFill>
+                <a:latin typeface="Calibri"/>
+              </a:rPr>
+              <a:t>deck</a:t>
+            </a:r>
+          </a:p>
+        </p:txBody>
+      </p:sp>
+      <p:sp>
+        <p:nvSpPr>
+          <p:cNvPr id="25" name="TextBox 24"/>
+          <p:cNvSpPr txBox="1"/>
+          <p:nvPr/>
+        </p:nvSpPr>
+        <p:spPr>
+          <a:xfrm>
+            <a:off x="502920" y="4617720"/>
+            <a:ext cx="10515600" cy="365760"/>
+          </a:xfrm>
+          <a:prstGeom prst="rect">
+            <a:avLst/>
+          </a:prstGeom>
+          <a:noFill/>
+        </p:spPr>
+        <p:txBody>
+          <a:bodyPr wrap="square">
+            <a:noAutofit/>
+          </a:bodyPr>
+          <a:lstStyle/>
+          <a:p>
+            <a:pPr algn="l"/>
+            <a:r>
+              <a:rPr sz="1100" b="0" i="1">
+                <a:solidFill>
+                  <a:srgbClr val="D6D3D1"/>
+                </a:solidFill>
+                <a:latin typeface="Calibri"/>
+              </a:rPr>
+              <a:t>Technical deep-dive  ·  single-file React architecture  ·  state model  ·  entity &amp; mandate logic  ·  design system</a:t>
+            </a:r>
+          </a:p>
+        </p:txBody>
+      </p:sp>
+      <p:sp>
+        <p:nvSpPr>
+          <p:cNvPr id="26" name="TextBox 25"/>
+          <p:cNvSpPr txBox="1"/>
+          <p:nvPr/>
+        </p:nvSpPr>
+        <p:spPr>
+          <a:xfrm>
+            <a:off x="502920" y="6446520"/>
+            <a:ext cx="10058400" cy="310896"/>
+          </a:xfrm>
+          <a:prstGeom prst="rect">
+            <a:avLst/>
+          </a:prstGeom>
+          <a:noFill/>
+        </p:spPr>
+        <p:txBody>
+          <a:bodyPr wrap="square">
+            <a:noAutofit/>
+          </a:bodyPr>
+          <a:lstStyle/>
+          <a:p>
+            <a:pPr algn="l"/>
+            <a:r>
+              <a:rPr sz="1000" b="0" i="0">
+                <a:solidFill>
+                  <a:srgbClr val="FECACA"/>
+                </a:solidFill>
+                <a:latin typeface="Calibri"/>
+              </a:rPr>
+              <a:t>Alan Davidson  ·  Business Banking Advisor  ·  Self-initiated  ·  June 2026</a:t>
+            </a:r>
+          </a:p>
+        </p:txBody>
+      </p:sp>
+      <p:sp>
+        <p:nvSpPr>
+          <p:cNvPr id="27" name="Rectangle 26"/>
           <p:cNvSpPr/>
           <p:nvPr/>
         </p:nvSpPr>
         <p:spPr>
           <a:xfrm>
-            <a:off x="7909560" y="3520440"/>
-            <a:ext cx="2286000" cy="45720"/>
+            <a:off x="10012680" y="274320"/>
+            <a:ext cx="1783080" cy="310896"/>
           </a:xfrm>
           <a:prstGeom prst="rect">
             <a:avLst/>
@@ -3940,189 +4080,6 @@
       </p:sp>
       <p:sp>
         <p:nvSpPr>
-          <p:cNvPr id="23" name="TextBox 22"/>
-          <p:cNvSpPr txBox="1"/>
-          <p:nvPr/>
-        </p:nvSpPr>
-        <p:spPr>
-          <a:xfrm>
-            <a:off x="8019288" y="3584448"/>
-            <a:ext cx="2103120" cy="457200"/>
-          </a:xfrm>
-          <a:prstGeom prst="rect">
-            <a:avLst/>
-          </a:prstGeom>
-          <a:noFill/>
-        </p:spPr>
-        <p:txBody>
-          <a:bodyPr wrap="square">
-            <a:noAutofit/>
-          </a:bodyPr>
-          <a:lstStyle/>
-          <a:p>
-            <a:pPr algn="l"/>
-            <a:r>
-              <a:rPr sz="2400" b="1" i="0">
-                <a:solidFill>
-                  <a:srgbClr val="FFFFFF"/>
-                </a:solidFill>
-                <a:latin typeface="Calibri"/>
-              </a:rPr>
-              <a:t>16:9</a:t>
-            </a:r>
-          </a:p>
-        </p:txBody>
-      </p:sp>
-      <p:sp>
-        <p:nvSpPr>
-          <p:cNvPr id="24" name="TextBox 23"/>
-          <p:cNvSpPr txBox="1"/>
-          <p:nvPr/>
-        </p:nvSpPr>
-        <p:spPr>
-          <a:xfrm>
-            <a:off x="8037576" y="4041648"/>
-            <a:ext cx="2011680" cy="256032"/>
-          </a:xfrm>
-          <a:prstGeom prst="rect">
-            <a:avLst/>
-          </a:prstGeom>
-          <a:noFill/>
-        </p:spPr>
-        <p:txBody>
-          <a:bodyPr wrap="square">
-            <a:noAutofit/>
-          </a:bodyPr>
-          <a:lstStyle/>
-          <a:p>
-            <a:pPr algn="l"/>
-            <a:r>
-              <a:rPr sz="900" b="0" i="0">
-                <a:solidFill>
-                  <a:srgbClr val="D6D3D1"/>
-                </a:solidFill>
-                <a:latin typeface="Calibri"/>
-              </a:rPr>
-              <a:t>deck</a:t>
-            </a:r>
-          </a:p>
-        </p:txBody>
-      </p:sp>
-      <p:sp>
-        <p:nvSpPr>
-          <p:cNvPr id="25" name="TextBox 24"/>
-          <p:cNvSpPr txBox="1"/>
-          <p:nvPr/>
-        </p:nvSpPr>
-        <p:spPr>
-          <a:xfrm>
-            <a:off x="502920" y="4617720"/>
-            <a:ext cx="10515600" cy="365760"/>
-          </a:xfrm>
-          <a:prstGeom prst="rect">
-            <a:avLst/>
-          </a:prstGeom>
-          <a:noFill/>
-        </p:spPr>
-        <p:txBody>
-          <a:bodyPr wrap="square">
-            <a:noAutofit/>
-          </a:bodyPr>
-          <a:lstStyle/>
-          <a:p>
-            <a:pPr algn="l"/>
-            <a:r>
-              <a:rPr sz="1100" b="0" i="1">
-                <a:solidFill>
-                  <a:srgbClr val="D6D3D1"/>
-                </a:solidFill>
-                <a:latin typeface="Calibri"/>
-              </a:rPr>
-              <a:t>Technical deep-dive  ·  single-file React architecture  ·  state model  ·  entity &amp; mandate logic  ·  design system</a:t>
-            </a:r>
-          </a:p>
-        </p:txBody>
-      </p:sp>
-      <p:sp>
-        <p:nvSpPr>
-          <p:cNvPr id="26" name="TextBox 25"/>
-          <p:cNvSpPr txBox="1"/>
-          <p:nvPr/>
-        </p:nvSpPr>
-        <p:spPr>
-          <a:xfrm>
-            <a:off x="502920" y="6446520"/>
-            <a:ext cx="10058400" cy="310896"/>
-          </a:xfrm>
-          <a:prstGeom prst="rect">
-            <a:avLst/>
-          </a:prstGeom>
-          <a:noFill/>
-        </p:spPr>
-        <p:txBody>
-          <a:bodyPr wrap="square">
-            <a:noAutofit/>
-          </a:bodyPr>
-          <a:lstStyle/>
-          <a:p>
-            <a:pPr algn="l"/>
-            <a:r>
-              <a:rPr sz="1000" b="0" i="0">
-                <a:solidFill>
-                  <a:srgbClr val="FECACA"/>
-                </a:solidFill>
-                <a:latin typeface="Calibri"/>
-              </a:rPr>
-              <a:t>Alan Davidson  ·  Business Banking Advisor  ·  Self-initiated  ·  June 2026</a:t>
-            </a:r>
-          </a:p>
-        </p:txBody>
-      </p:sp>
-      <p:sp>
-        <p:nvSpPr>
-          <p:cNvPr id="27" name="Rectangle 26"/>
-          <p:cNvSpPr/>
-          <p:nvPr/>
-        </p:nvSpPr>
-        <p:spPr>
-          <a:xfrm>
-            <a:off x="10012680" y="274320"/>
-            <a:ext cx="1783080" cy="310896"/>
-          </a:xfrm>
-          <a:prstGeom prst="rect">
-            <a:avLst/>
-          </a:prstGeom>
-          <a:solidFill>
-            <a:srgbClr val="DA291C"/>
-          </a:solidFill>
-          <a:ln>
-            <a:noFill/>
-          </a:ln>
-        </p:spPr>
-        <p:style>
-          <a:lnRef idx="1">
-            <a:schemeClr val="accent1"/>
-          </a:lnRef>
-          <a:fillRef idx="3">
-            <a:schemeClr val="accent1"/>
-          </a:fillRef>
-          <a:effectRef idx="2">
-            <a:schemeClr val="accent1"/>
-          </a:effectRef>
-          <a:fontRef idx="minor">
-            <a:schemeClr val="lt1"/>
-          </a:fontRef>
-        </p:style>
-        <p:txBody>
-          <a:bodyPr rtlCol="0" anchor="ctr"/>
-          <a:lstStyle/>
-          <a:p>
-            <a:pPr algn="ctr"/>
-          </a:p>
-        </p:txBody>
-      </p:sp>
-      <p:sp>
-        <p:nvSpPr>
           <p:cNvPr id="28" name="TextBox 27"/>
           <p:cNvSpPr txBox="1"/>
           <p:nvPr/>
@@ -4156,6 +4113,30 @@
           </a:p>
         </p:txBody>
       </p:sp>
+      <p:pic>
+        <p:nvPicPr>
+          <p:cNvPr id="29" name="Santander logo" descr="santander-logo-white.png"/>
+          <p:cNvPicPr>
+            <a:picLocks noChangeAspect="1"/>
+          </p:cNvPicPr>
+          <p:nvPr/>
+        </p:nvPicPr>
+        <p:blipFill>
+          <a:blip r:embed="rId2"/>
+          <a:stretch>
+            <a:fillRect/>
+          </a:stretch>
+        </p:blipFill>
+        <p:spPr>
+          <a:xfrm>
+            <a:off x="502920" y="457200"/>
+            <a:ext cx="2377440" cy="411297"/>
+          </a:xfrm>
+          <a:prstGeom prst="rect">
+            <a:avLst/>
+          </a:prstGeom>
+        </p:spPr>
+      </p:pic>
     </p:spTree>
   </p:cSld>
   <p:clrMapOvr>

</xml_diff>